<commit_message>
chore(freep/corpus): add 05-table deck + regenerate existing corpus pptx files
05-table: 3-col x 4-row table with header row, alternating band fills, and a
merged cell in the last row. Generated via CorpusGenerator.GenerateTable.

Reference PNG: PowerPoint render used as ground truth for --compare.

Existing deck binaries updated (minor size change from PowerPoint 2024 adding
a16:rowId/colId extension elements — no functional change).

Co-Authored-By: Claude Opus 4.8 <noreply@anthropic.com>
</commit_message>
<xml_diff>
--- a/tools/FreeP.RenderCompare/corpus/01-title-slide.pptx
+++ b/tools/FreeP.RenderCompare/corpus/01-title-slide.pptx
@@ -129,7 +129,7 @@
           <p:cNvPr id="2" name="Title 1">
             <a:extLst>
               <a:ext uri="{FF2B5EF4-FFF2-40B4-BE49-F238E27FC236}">
-                <a16:creationId xmlns:a16="http://schemas.microsoft.com/office/drawing/2014/main" id="{F503E054-20E5-1FD0-023D-F516D1D50431}"/>
+                <a16:creationId xmlns:a16="http://schemas.microsoft.com/office/drawing/2014/main" id="{A126DF29-B1FF-008B-7EC8-3D3A78F563EF}"/>
               </a:ext>
             </a:extLst>
           </p:cNvPr>
@@ -166,7 +166,7 @@
           <p:cNvPr id="3" name="Subtitle 2">
             <a:extLst>
               <a:ext uri="{FF2B5EF4-FFF2-40B4-BE49-F238E27FC236}">
-                <a16:creationId xmlns:a16="http://schemas.microsoft.com/office/drawing/2014/main" id="{94E74E81-5896-A9CF-67B8-4FB4CD410B9C}"/>
+                <a16:creationId xmlns:a16="http://schemas.microsoft.com/office/drawing/2014/main" id="{35F67562-2779-69A0-1330-0094BDD6B0A9}"/>
               </a:ext>
             </a:extLst>
           </p:cNvPr>
@@ -236,7 +236,7 @@
           <p:cNvPr id="4" name="Date Placeholder 3">
             <a:extLst>
               <a:ext uri="{FF2B5EF4-FFF2-40B4-BE49-F238E27FC236}">
-                <a16:creationId xmlns:a16="http://schemas.microsoft.com/office/drawing/2014/main" id="{FE564057-3BFE-04B4-31A4-095A00B0A754}"/>
+                <a16:creationId xmlns:a16="http://schemas.microsoft.com/office/drawing/2014/main" id="{08CFAD3A-CCC8-EF7B-4B62-FDBAAC1CDC87}"/>
               </a:ext>
             </a:extLst>
           </p:cNvPr>
@@ -252,7 +252,7 @@
           <a:bodyPr/>
           <a:lstStyle/>
           <a:p>
-            <a:fld id="{CEA65F65-8E5A-4520-9F6B-2B300F18C5FA}" type="datetimeFigureOut">
+            <a:fld id="{D0DC34CB-9D0C-46D2-AF83-D9E99F6E08AA}" type="datetimeFigureOut">
               <a:rPr lang="en-US" smtClean="0"/>
               <a:t>6/25/2026</a:t>
             </a:fld>
@@ -265,7 +265,7 @@
           <p:cNvPr id="5" name="Footer Placeholder 4">
             <a:extLst>
               <a:ext uri="{FF2B5EF4-FFF2-40B4-BE49-F238E27FC236}">
-                <a16:creationId xmlns:a16="http://schemas.microsoft.com/office/drawing/2014/main" id="{2FB001BE-7AC7-7548-0D8B-C1D53C110B7B}"/>
+                <a16:creationId xmlns:a16="http://schemas.microsoft.com/office/drawing/2014/main" id="{34EEBD82-30B7-740B-773C-08ED3C41A576}"/>
               </a:ext>
             </a:extLst>
           </p:cNvPr>
@@ -290,7 +290,7 @@
           <p:cNvPr id="6" name="Slide Number Placeholder 5">
             <a:extLst>
               <a:ext uri="{FF2B5EF4-FFF2-40B4-BE49-F238E27FC236}">
-                <a16:creationId xmlns:a16="http://schemas.microsoft.com/office/drawing/2014/main" id="{588D6832-A927-A46D-D659-15981514856F}"/>
+                <a16:creationId xmlns:a16="http://schemas.microsoft.com/office/drawing/2014/main" id="{6E389BAF-C914-908D-5DDD-8AC913451EE0}"/>
               </a:ext>
             </a:extLst>
           </p:cNvPr>
@@ -306,7 +306,7 @@
           <a:bodyPr/>
           <a:lstStyle/>
           <a:p>
-            <a:fld id="{8ED8B9E9-2D87-4FA9-AB16-BA1525BB403E}" type="slidenum">
+            <a:fld id="{51417EEE-D195-4768-ADC3-D10258B34F23}" type="slidenum">
               <a:rPr lang="en-US" smtClean="0"/>
               <a:t>‹#›</a:t>
             </a:fld>
@@ -317,7 +317,7 @@
     </p:spTree>
     <p:extLst>
       <p:ext uri="{BB962C8B-B14F-4D97-AF65-F5344CB8AC3E}">
-        <p14:creationId xmlns:p14="http://schemas.microsoft.com/office/powerpoint/2010/main" val="2286000484"/>
+        <p14:creationId xmlns:p14="http://schemas.microsoft.com/office/powerpoint/2010/main" val="2023766383"/>
       </p:ext>
     </p:extLst>
   </p:cSld>
@@ -349,7 +349,7 @@
           <p:cNvPr id="2" name="Title 1">
             <a:extLst>
               <a:ext uri="{FF2B5EF4-FFF2-40B4-BE49-F238E27FC236}">
-                <a16:creationId xmlns:a16="http://schemas.microsoft.com/office/drawing/2014/main" id="{77AE5D14-44D0-3F87-A211-01F4D9AB2117}"/>
+                <a16:creationId xmlns:a16="http://schemas.microsoft.com/office/drawing/2014/main" id="{186F7801-93A4-9CE9-8AD9-66E1894DD856}"/>
               </a:ext>
             </a:extLst>
           </p:cNvPr>
@@ -377,7 +377,7 @@
           <p:cNvPr id="3" name="Vertical Text Placeholder 2">
             <a:extLst>
               <a:ext uri="{FF2B5EF4-FFF2-40B4-BE49-F238E27FC236}">
-                <a16:creationId xmlns:a16="http://schemas.microsoft.com/office/drawing/2014/main" id="{6C664619-CFC4-FA8C-3D5F-C4AB3371BF22}"/>
+                <a16:creationId xmlns:a16="http://schemas.microsoft.com/office/drawing/2014/main" id="{61C1A588-52B4-31C0-B55A-76A2E8A691AA}"/>
               </a:ext>
             </a:extLst>
           </p:cNvPr>
@@ -434,7 +434,7 @@
           <p:cNvPr id="4" name="Date Placeholder 3">
             <a:extLst>
               <a:ext uri="{FF2B5EF4-FFF2-40B4-BE49-F238E27FC236}">
-                <a16:creationId xmlns:a16="http://schemas.microsoft.com/office/drawing/2014/main" id="{3D586CE3-E6AD-B07D-2AAF-F2DA5267A881}"/>
+                <a16:creationId xmlns:a16="http://schemas.microsoft.com/office/drawing/2014/main" id="{326E43AC-DE41-99D4-59CA-9CC7343F7F1A}"/>
               </a:ext>
             </a:extLst>
           </p:cNvPr>
@@ -450,7 +450,7 @@
           <a:bodyPr/>
           <a:lstStyle/>
           <a:p>
-            <a:fld id="{CEA65F65-8E5A-4520-9F6B-2B300F18C5FA}" type="datetimeFigureOut">
+            <a:fld id="{D0DC34CB-9D0C-46D2-AF83-D9E99F6E08AA}" type="datetimeFigureOut">
               <a:rPr lang="en-US" smtClean="0"/>
               <a:t>6/25/2026</a:t>
             </a:fld>
@@ -463,7 +463,7 @@
           <p:cNvPr id="5" name="Footer Placeholder 4">
             <a:extLst>
               <a:ext uri="{FF2B5EF4-FFF2-40B4-BE49-F238E27FC236}">
-                <a16:creationId xmlns:a16="http://schemas.microsoft.com/office/drawing/2014/main" id="{1B8FDB85-91B0-D5CC-CD39-E57AF9DBE6E3}"/>
+                <a16:creationId xmlns:a16="http://schemas.microsoft.com/office/drawing/2014/main" id="{DE42D85F-89DD-519D-D3EB-921ADB975EB4}"/>
               </a:ext>
             </a:extLst>
           </p:cNvPr>
@@ -488,7 +488,7 @@
           <p:cNvPr id="6" name="Slide Number Placeholder 5">
             <a:extLst>
               <a:ext uri="{FF2B5EF4-FFF2-40B4-BE49-F238E27FC236}">
-                <a16:creationId xmlns:a16="http://schemas.microsoft.com/office/drawing/2014/main" id="{0F0E041D-8B93-0CFC-5318-B4F7FA74EE9F}"/>
+                <a16:creationId xmlns:a16="http://schemas.microsoft.com/office/drawing/2014/main" id="{104D729A-13FB-AC39-0859-C33F995B5D19}"/>
               </a:ext>
             </a:extLst>
           </p:cNvPr>
@@ -504,7 +504,7 @@
           <a:bodyPr/>
           <a:lstStyle/>
           <a:p>
-            <a:fld id="{8ED8B9E9-2D87-4FA9-AB16-BA1525BB403E}" type="slidenum">
+            <a:fld id="{51417EEE-D195-4768-ADC3-D10258B34F23}" type="slidenum">
               <a:rPr lang="en-US" smtClean="0"/>
               <a:t>‹#›</a:t>
             </a:fld>
@@ -515,7 +515,7 @@
     </p:spTree>
     <p:extLst>
       <p:ext uri="{BB962C8B-B14F-4D97-AF65-F5344CB8AC3E}">
-        <p14:creationId xmlns:p14="http://schemas.microsoft.com/office/powerpoint/2010/main" val="1157246049"/>
+        <p14:creationId xmlns:p14="http://schemas.microsoft.com/office/powerpoint/2010/main" val="1854278570"/>
       </p:ext>
     </p:extLst>
   </p:cSld>
@@ -547,7 +547,7 @@
           <p:cNvPr id="2" name="Vertical Title 1">
             <a:extLst>
               <a:ext uri="{FF2B5EF4-FFF2-40B4-BE49-F238E27FC236}">
-                <a16:creationId xmlns:a16="http://schemas.microsoft.com/office/drawing/2014/main" id="{F311EF34-3BF3-B4C3-5296-4F7277E530AC}"/>
+                <a16:creationId xmlns:a16="http://schemas.microsoft.com/office/drawing/2014/main" id="{F1CFEF52-0623-553F-0CF5-8F52DB8F1912}"/>
               </a:ext>
             </a:extLst>
           </p:cNvPr>
@@ -580,7 +580,7 @@
           <p:cNvPr id="3" name="Vertical Text Placeholder 2">
             <a:extLst>
               <a:ext uri="{FF2B5EF4-FFF2-40B4-BE49-F238E27FC236}">
-                <a16:creationId xmlns:a16="http://schemas.microsoft.com/office/drawing/2014/main" id="{ECDD9CE6-5AA7-4CA5-3CB9-74BCE501DEC0}"/>
+                <a16:creationId xmlns:a16="http://schemas.microsoft.com/office/drawing/2014/main" id="{6E07F1D8-274D-1985-778B-ADE64AE580FA}"/>
               </a:ext>
             </a:extLst>
           </p:cNvPr>
@@ -642,7 +642,7 @@
           <p:cNvPr id="4" name="Date Placeholder 3">
             <a:extLst>
               <a:ext uri="{FF2B5EF4-FFF2-40B4-BE49-F238E27FC236}">
-                <a16:creationId xmlns:a16="http://schemas.microsoft.com/office/drawing/2014/main" id="{670844C0-C736-17A1-A0A8-A5E35754B31A}"/>
+                <a16:creationId xmlns:a16="http://schemas.microsoft.com/office/drawing/2014/main" id="{019B3D65-CE55-773A-123D-335A9846802F}"/>
               </a:ext>
             </a:extLst>
           </p:cNvPr>
@@ -658,7 +658,7 @@
           <a:bodyPr/>
           <a:lstStyle/>
           <a:p>
-            <a:fld id="{CEA65F65-8E5A-4520-9F6B-2B300F18C5FA}" type="datetimeFigureOut">
+            <a:fld id="{D0DC34CB-9D0C-46D2-AF83-D9E99F6E08AA}" type="datetimeFigureOut">
               <a:rPr lang="en-US" smtClean="0"/>
               <a:t>6/25/2026</a:t>
             </a:fld>
@@ -671,7 +671,7 @@
           <p:cNvPr id="5" name="Footer Placeholder 4">
             <a:extLst>
               <a:ext uri="{FF2B5EF4-FFF2-40B4-BE49-F238E27FC236}">
-                <a16:creationId xmlns:a16="http://schemas.microsoft.com/office/drawing/2014/main" id="{0504B508-BDBF-4507-1203-BE407869A9C5}"/>
+                <a16:creationId xmlns:a16="http://schemas.microsoft.com/office/drawing/2014/main" id="{E32AD37B-5926-BB1E-D301-A5D96E42FC49}"/>
               </a:ext>
             </a:extLst>
           </p:cNvPr>
@@ -696,7 +696,7 @@
           <p:cNvPr id="6" name="Slide Number Placeholder 5">
             <a:extLst>
               <a:ext uri="{FF2B5EF4-FFF2-40B4-BE49-F238E27FC236}">
-                <a16:creationId xmlns:a16="http://schemas.microsoft.com/office/drawing/2014/main" id="{9F6D0AAF-E591-5FFE-7B29-DDB6407AAFB9}"/>
+                <a16:creationId xmlns:a16="http://schemas.microsoft.com/office/drawing/2014/main" id="{47F4A8BF-B59A-D1D1-C925-03C13BDD26C6}"/>
               </a:ext>
             </a:extLst>
           </p:cNvPr>
@@ -712,7 +712,7 @@
           <a:bodyPr/>
           <a:lstStyle/>
           <a:p>
-            <a:fld id="{8ED8B9E9-2D87-4FA9-AB16-BA1525BB403E}" type="slidenum">
+            <a:fld id="{51417EEE-D195-4768-ADC3-D10258B34F23}" type="slidenum">
               <a:rPr lang="en-US" smtClean="0"/>
               <a:t>‹#›</a:t>
             </a:fld>
@@ -723,7 +723,7 @@
     </p:spTree>
     <p:extLst>
       <p:ext uri="{BB962C8B-B14F-4D97-AF65-F5344CB8AC3E}">
-        <p14:creationId xmlns:p14="http://schemas.microsoft.com/office/powerpoint/2010/main" val="1429348192"/>
+        <p14:creationId xmlns:p14="http://schemas.microsoft.com/office/powerpoint/2010/main" val="2353762714"/>
       </p:ext>
     </p:extLst>
   </p:cSld>
@@ -755,7 +755,7 @@
           <p:cNvPr id="2" name="Title 1">
             <a:extLst>
               <a:ext uri="{FF2B5EF4-FFF2-40B4-BE49-F238E27FC236}">
-                <a16:creationId xmlns:a16="http://schemas.microsoft.com/office/drawing/2014/main" id="{E078B89E-44FA-ACB2-4AAE-D78C9BAC20E1}"/>
+                <a16:creationId xmlns:a16="http://schemas.microsoft.com/office/drawing/2014/main" id="{E4E2AE3D-FBD6-BEA1-A4E2-7A9B878A57B1}"/>
               </a:ext>
             </a:extLst>
           </p:cNvPr>
@@ -783,7 +783,7 @@
           <p:cNvPr id="3" name="Content Placeholder 2">
             <a:extLst>
               <a:ext uri="{FF2B5EF4-FFF2-40B4-BE49-F238E27FC236}">
-                <a16:creationId xmlns:a16="http://schemas.microsoft.com/office/drawing/2014/main" id="{763F3089-C47E-3193-DDF3-077DC071B7F6}"/>
+                <a16:creationId xmlns:a16="http://schemas.microsoft.com/office/drawing/2014/main" id="{88904176-05B4-071C-2C70-B57E54ADAA48}"/>
               </a:ext>
             </a:extLst>
           </p:cNvPr>
@@ -840,7 +840,7 @@
           <p:cNvPr id="4" name="Date Placeholder 3">
             <a:extLst>
               <a:ext uri="{FF2B5EF4-FFF2-40B4-BE49-F238E27FC236}">
-                <a16:creationId xmlns:a16="http://schemas.microsoft.com/office/drawing/2014/main" id="{92EF1A0D-D03F-AA08-E1B3-DD2B5A46CB19}"/>
+                <a16:creationId xmlns:a16="http://schemas.microsoft.com/office/drawing/2014/main" id="{B2757395-04ED-9729-701C-133174037C06}"/>
               </a:ext>
             </a:extLst>
           </p:cNvPr>
@@ -856,7 +856,7 @@
           <a:bodyPr/>
           <a:lstStyle/>
           <a:p>
-            <a:fld id="{CEA65F65-8E5A-4520-9F6B-2B300F18C5FA}" type="datetimeFigureOut">
+            <a:fld id="{D0DC34CB-9D0C-46D2-AF83-D9E99F6E08AA}" type="datetimeFigureOut">
               <a:rPr lang="en-US" smtClean="0"/>
               <a:t>6/25/2026</a:t>
             </a:fld>
@@ -869,7 +869,7 @@
           <p:cNvPr id="5" name="Footer Placeholder 4">
             <a:extLst>
               <a:ext uri="{FF2B5EF4-FFF2-40B4-BE49-F238E27FC236}">
-                <a16:creationId xmlns:a16="http://schemas.microsoft.com/office/drawing/2014/main" id="{410E3F19-6E46-75CB-4A39-98C28071BA52}"/>
+                <a16:creationId xmlns:a16="http://schemas.microsoft.com/office/drawing/2014/main" id="{6C283D45-0762-E4BA-9865-41DFF100EF91}"/>
               </a:ext>
             </a:extLst>
           </p:cNvPr>
@@ -894,7 +894,7 @@
           <p:cNvPr id="6" name="Slide Number Placeholder 5">
             <a:extLst>
               <a:ext uri="{FF2B5EF4-FFF2-40B4-BE49-F238E27FC236}">
-                <a16:creationId xmlns:a16="http://schemas.microsoft.com/office/drawing/2014/main" id="{72231A7E-5032-B05F-992B-CDCB7AD5A05D}"/>
+                <a16:creationId xmlns:a16="http://schemas.microsoft.com/office/drawing/2014/main" id="{4808E48F-2DF9-71FF-F9D4-348DC68F2D4E}"/>
               </a:ext>
             </a:extLst>
           </p:cNvPr>
@@ -910,7 +910,7 @@
           <a:bodyPr/>
           <a:lstStyle/>
           <a:p>
-            <a:fld id="{8ED8B9E9-2D87-4FA9-AB16-BA1525BB403E}" type="slidenum">
+            <a:fld id="{51417EEE-D195-4768-ADC3-D10258B34F23}" type="slidenum">
               <a:rPr lang="en-US" smtClean="0"/>
               <a:t>‹#›</a:t>
             </a:fld>
@@ -921,7 +921,7 @@
     </p:spTree>
     <p:extLst>
       <p:ext uri="{BB962C8B-B14F-4D97-AF65-F5344CB8AC3E}">
-        <p14:creationId xmlns:p14="http://schemas.microsoft.com/office/powerpoint/2010/main" val="740422528"/>
+        <p14:creationId xmlns:p14="http://schemas.microsoft.com/office/powerpoint/2010/main" val="1220380307"/>
       </p:ext>
     </p:extLst>
   </p:cSld>
@@ -953,7 +953,7 @@
           <p:cNvPr id="2" name="Title 1">
             <a:extLst>
               <a:ext uri="{FF2B5EF4-FFF2-40B4-BE49-F238E27FC236}">
-                <a16:creationId xmlns:a16="http://schemas.microsoft.com/office/drawing/2014/main" id="{22572B08-50C9-BEF3-BC51-FF5559298403}"/>
+                <a16:creationId xmlns:a16="http://schemas.microsoft.com/office/drawing/2014/main" id="{5C277243-153D-35AD-D536-06D49EFCAB36}"/>
               </a:ext>
             </a:extLst>
           </p:cNvPr>
@@ -990,7 +990,7 @@
           <p:cNvPr id="3" name="Text Placeholder 2">
             <a:extLst>
               <a:ext uri="{FF2B5EF4-FFF2-40B4-BE49-F238E27FC236}">
-                <a16:creationId xmlns:a16="http://schemas.microsoft.com/office/drawing/2014/main" id="{6598477D-28B6-0873-2BCA-99C9A513DE02}"/>
+                <a16:creationId xmlns:a16="http://schemas.microsoft.com/office/drawing/2014/main" id="{EFA6A44C-49FF-9476-2ADE-B1EC2CDD013F}"/>
               </a:ext>
             </a:extLst>
           </p:cNvPr>
@@ -1115,7 +1115,7 @@
           <p:cNvPr id="4" name="Date Placeholder 3">
             <a:extLst>
               <a:ext uri="{FF2B5EF4-FFF2-40B4-BE49-F238E27FC236}">
-                <a16:creationId xmlns:a16="http://schemas.microsoft.com/office/drawing/2014/main" id="{318A83E0-1AFD-492F-A232-B0B26D9EA0D6}"/>
+                <a16:creationId xmlns:a16="http://schemas.microsoft.com/office/drawing/2014/main" id="{193353AA-5D9E-37E5-E663-719F7EE08587}"/>
               </a:ext>
             </a:extLst>
           </p:cNvPr>
@@ -1131,7 +1131,7 @@
           <a:bodyPr/>
           <a:lstStyle/>
           <a:p>
-            <a:fld id="{CEA65F65-8E5A-4520-9F6B-2B300F18C5FA}" type="datetimeFigureOut">
+            <a:fld id="{D0DC34CB-9D0C-46D2-AF83-D9E99F6E08AA}" type="datetimeFigureOut">
               <a:rPr lang="en-US" smtClean="0"/>
               <a:t>6/25/2026</a:t>
             </a:fld>
@@ -1144,7 +1144,7 @@
           <p:cNvPr id="5" name="Footer Placeholder 4">
             <a:extLst>
               <a:ext uri="{FF2B5EF4-FFF2-40B4-BE49-F238E27FC236}">
-                <a16:creationId xmlns:a16="http://schemas.microsoft.com/office/drawing/2014/main" id="{9F5DA7C5-7956-24C7-69C8-8B23577809CE}"/>
+                <a16:creationId xmlns:a16="http://schemas.microsoft.com/office/drawing/2014/main" id="{645D1295-88CC-5EED-83CB-53E4F75D84E2}"/>
               </a:ext>
             </a:extLst>
           </p:cNvPr>
@@ -1169,7 +1169,7 @@
           <p:cNvPr id="6" name="Slide Number Placeholder 5">
             <a:extLst>
               <a:ext uri="{FF2B5EF4-FFF2-40B4-BE49-F238E27FC236}">
-                <a16:creationId xmlns:a16="http://schemas.microsoft.com/office/drawing/2014/main" id="{29D4822B-64A2-9A77-18DF-B58AF70AD0C3}"/>
+                <a16:creationId xmlns:a16="http://schemas.microsoft.com/office/drawing/2014/main" id="{E798EE99-055A-D476-F5EB-0C17E2E93467}"/>
               </a:ext>
             </a:extLst>
           </p:cNvPr>
@@ -1185,7 +1185,7 @@
           <a:bodyPr/>
           <a:lstStyle/>
           <a:p>
-            <a:fld id="{8ED8B9E9-2D87-4FA9-AB16-BA1525BB403E}" type="slidenum">
+            <a:fld id="{51417EEE-D195-4768-ADC3-D10258B34F23}" type="slidenum">
               <a:rPr lang="en-US" smtClean="0"/>
               <a:t>‹#›</a:t>
             </a:fld>
@@ -1196,7 +1196,7 @@
     </p:spTree>
     <p:extLst>
       <p:ext uri="{BB962C8B-B14F-4D97-AF65-F5344CB8AC3E}">
-        <p14:creationId xmlns:p14="http://schemas.microsoft.com/office/powerpoint/2010/main" val="2753808710"/>
+        <p14:creationId xmlns:p14="http://schemas.microsoft.com/office/powerpoint/2010/main" val="1819538815"/>
       </p:ext>
     </p:extLst>
   </p:cSld>
@@ -1228,7 +1228,7 @@
           <p:cNvPr id="2" name="Title 1">
             <a:extLst>
               <a:ext uri="{FF2B5EF4-FFF2-40B4-BE49-F238E27FC236}">
-                <a16:creationId xmlns:a16="http://schemas.microsoft.com/office/drawing/2014/main" id="{EF26EB70-6D70-DEED-774F-90ACD3BA55F7}"/>
+                <a16:creationId xmlns:a16="http://schemas.microsoft.com/office/drawing/2014/main" id="{76FD9A12-7847-12FC-631E-9B723D8F9C44}"/>
               </a:ext>
             </a:extLst>
           </p:cNvPr>
@@ -1256,7 +1256,7 @@
           <p:cNvPr id="3" name="Content Placeholder 2">
             <a:extLst>
               <a:ext uri="{FF2B5EF4-FFF2-40B4-BE49-F238E27FC236}">
-                <a16:creationId xmlns:a16="http://schemas.microsoft.com/office/drawing/2014/main" id="{429B4F8B-6E4B-5C30-2B02-78CFE22F76BC}"/>
+                <a16:creationId xmlns:a16="http://schemas.microsoft.com/office/drawing/2014/main" id="{4983E0CB-9BBD-BEB4-AB91-61F68D1F172D}"/>
               </a:ext>
             </a:extLst>
           </p:cNvPr>
@@ -1318,7 +1318,7 @@
           <p:cNvPr id="4" name="Content Placeholder 3">
             <a:extLst>
               <a:ext uri="{FF2B5EF4-FFF2-40B4-BE49-F238E27FC236}">
-                <a16:creationId xmlns:a16="http://schemas.microsoft.com/office/drawing/2014/main" id="{4A5199F1-CCB7-B7EB-D359-1D0884E2674A}"/>
+                <a16:creationId xmlns:a16="http://schemas.microsoft.com/office/drawing/2014/main" id="{F608B959-0CC3-F652-0D16-DFEF901A8786}"/>
               </a:ext>
             </a:extLst>
           </p:cNvPr>
@@ -1380,7 +1380,7 @@
           <p:cNvPr id="5" name="Date Placeholder 4">
             <a:extLst>
               <a:ext uri="{FF2B5EF4-FFF2-40B4-BE49-F238E27FC236}">
-                <a16:creationId xmlns:a16="http://schemas.microsoft.com/office/drawing/2014/main" id="{2A54A785-61D7-E411-299C-F7AA396ACC04}"/>
+                <a16:creationId xmlns:a16="http://schemas.microsoft.com/office/drawing/2014/main" id="{7D09EBF0-DC90-3F90-A5AA-4E8B9F53D596}"/>
               </a:ext>
             </a:extLst>
           </p:cNvPr>
@@ -1396,7 +1396,7 @@
           <a:bodyPr/>
           <a:lstStyle/>
           <a:p>
-            <a:fld id="{CEA65F65-8E5A-4520-9F6B-2B300F18C5FA}" type="datetimeFigureOut">
+            <a:fld id="{D0DC34CB-9D0C-46D2-AF83-D9E99F6E08AA}" type="datetimeFigureOut">
               <a:rPr lang="en-US" smtClean="0"/>
               <a:t>6/25/2026</a:t>
             </a:fld>
@@ -1409,7 +1409,7 @@
           <p:cNvPr id="6" name="Footer Placeholder 5">
             <a:extLst>
               <a:ext uri="{FF2B5EF4-FFF2-40B4-BE49-F238E27FC236}">
-                <a16:creationId xmlns:a16="http://schemas.microsoft.com/office/drawing/2014/main" id="{0E8BE93C-C807-9F1A-7543-19C4C5AC4617}"/>
+                <a16:creationId xmlns:a16="http://schemas.microsoft.com/office/drawing/2014/main" id="{32FF2393-B89D-C221-A730-A4E226AD5B53}"/>
               </a:ext>
             </a:extLst>
           </p:cNvPr>
@@ -1434,7 +1434,7 @@
           <p:cNvPr id="7" name="Slide Number Placeholder 6">
             <a:extLst>
               <a:ext uri="{FF2B5EF4-FFF2-40B4-BE49-F238E27FC236}">
-                <a16:creationId xmlns:a16="http://schemas.microsoft.com/office/drawing/2014/main" id="{00ACB317-953C-9433-5907-AB020C5D5E20}"/>
+                <a16:creationId xmlns:a16="http://schemas.microsoft.com/office/drawing/2014/main" id="{DC0B01AF-51C4-11BC-158A-E044D1735241}"/>
               </a:ext>
             </a:extLst>
           </p:cNvPr>
@@ -1450,7 +1450,7 @@
           <a:bodyPr/>
           <a:lstStyle/>
           <a:p>
-            <a:fld id="{8ED8B9E9-2D87-4FA9-AB16-BA1525BB403E}" type="slidenum">
+            <a:fld id="{51417EEE-D195-4768-ADC3-D10258B34F23}" type="slidenum">
               <a:rPr lang="en-US" smtClean="0"/>
               <a:t>‹#›</a:t>
             </a:fld>
@@ -1461,7 +1461,7 @@
     </p:spTree>
     <p:extLst>
       <p:ext uri="{BB962C8B-B14F-4D97-AF65-F5344CB8AC3E}">
-        <p14:creationId xmlns:p14="http://schemas.microsoft.com/office/powerpoint/2010/main" val="1423742169"/>
+        <p14:creationId xmlns:p14="http://schemas.microsoft.com/office/powerpoint/2010/main" val="2755836416"/>
       </p:ext>
     </p:extLst>
   </p:cSld>
@@ -1493,7 +1493,7 @@
           <p:cNvPr id="2" name="Title 1">
             <a:extLst>
               <a:ext uri="{FF2B5EF4-FFF2-40B4-BE49-F238E27FC236}">
-                <a16:creationId xmlns:a16="http://schemas.microsoft.com/office/drawing/2014/main" id="{3ED00631-4D2F-0E0F-8FF5-C767C27F7BB7}"/>
+                <a16:creationId xmlns:a16="http://schemas.microsoft.com/office/drawing/2014/main" id="{E7FB6399-F249-65B2-CF98-876F586C9D14}"/>
               </a:ext>
             </a:extLst>
           </p:cNvPr>
@@ -1526,7 +1526,7 @@
           <p:cNvPr id="3" name="Text Placeholder 2">
             <a:extLst>
               <a:ext uri="{FF2B5EF4-FFF2-40B4-BE49-F238E27FC236}">
-                <a16:creationId xmlns:a16="http://schemas.microsoft.com/office/drawing/2014/main" id="{E1463394-3656-97EA-2291-9D9D2097FD64}"/>
+                <a16:creationId xmlns:a16="http://schemas.microsoft.com/office/drawing/2014/main" id="{42EAED86-FF78-E8D7-7E1E-C93D29D77950}"/>
               </a:ext>
             </a:extLst>
           </p:cNvPr>
@@ -1597,7 +1597,7 @@
           <p:cNvPr id="4" name="Content Placeholder 3">
             <a:extLst>
               <a:ext uri="{FF2B5EF4-FFF2-40B4-BE49-F238E27FC236}">
-                <a16:creationId xmlns:a16="http://schemas.microsoft.com/office/drawing/2014/main" id="{F4C45AC6-4996-D414-7200-BFBC31B92A56}"/>
+                <a16:creationId xmlns:a16="http://schemas.microsoft.com/office/drawing/2014/main" id="{037EDCA0-0EB6-2E05-179C-52BBBC15804D}"/>
               </a:ext>
             </a:extLst>
           </p:cNvPr>
@@ -1659,7 +1659,7 @@
           <p:cNvPr id="5" name="Text Placeholder 4">
             <a:extLst>
               <a:ext uri="{FF2B5EF4-FFF2-40B4-BE49-F238E27FC236}">
-                <a16:creationId xmlns:a16="http://schemas.microsoft.com/office/drawing/2014/main" id="{7EDDD84E-B8B1-76CA-7A32-C879E43CFE34}"/>
+                <a16:creationId xmlns:a16="http://schemas.microsoft.com/office/drawing/2014/main" id="{E43A62CA-EF80-F6FE-4208-19EAEE28DF87}"/>
               </a:ext>
             </a:extLst>
           </p:cNvPr>
@@ -1730,7 +1730,7 @@
           <p:cNvPr id="6" name="Content Placeholder 5">
             <a:extLst>
               <a:ext uri="{FF2B5EF4-FFF2-40B4-BE49-F238E27FC236}">
-                <a16:creationId xmlns:a16="http://schemas.microsoft.com/office/drawing/2014/main" id="{413537BC-49F8-BBA0-CF03-F2D5D351CEDA}"/>
+                <a16:creationId xmlns:a16="http://schemas.microsoft.com/office/drawing/2014/main" id="{4894C1F4-0253-E62F-260E-C553A8562162}"/>
               </a:ext>
             </a:extLst>
           </p:cNvPr>
@@ -1792,7 +1792,7 @@
           <p:cNvPr id="7" name="Date Placeholder 6">
             <a:extLst>
               <a:ext uri="{FF2B5EF4-FFF2-40B4-BE49-F238E27FC236}">
-                <a16:creationId xmlns:a16="http://schemas.microsoft.com/office/drawing/2014/main" id="{A806C387-4813-B96C-8820-40B43AC9636E}"/>
+                <a16:creationId xmlns:a16="http://schemas.microsoft.com/office/drawing/2014/main" id="{602F7CF6-AC83-69B5-A37B-069FB899AF45}"/>
               </a:ext>
             </a:extLst>
           </p:cNvPr>
@@ -1808,7 +1808,7 @@
           <a:bodyPr/>
           <a:lstStyle/>
           <a:p>
-            <a:fld id="{CEA65F65-8E5A-4520-9F6B-2B300F18C5FA}" type="datetimeFigureOut">
+            <a:fld id="{D0DC34CB-9D0C-46D2-AF83-D9E99F6E08AA}" type="datetimeFigureOut">
               <a:rPr lang="en-US" smtClean="0"/>
               <a:t>6/25/2026</a:t>
             </a:fld>
@@ -1821,7 +1821,7 @@
           <p:cNvPr id="8" name="Footer Placeholder 7">
             <a:extLst>
               <a:ext uri="{FF2B5EF4-FFF2-40B4-BE49-F238E27FC236}">
-                <a16:creationId xmlns:a16="http://schemas.microsoft.com/office/drawing/2014/main" id="{520D9F9D-780C-0ECC-5854-C4C84B89CFC4}"/>
+                <a16:creationId xmlns:a16="http://schemas.microsoft.com/office/drawing/2014/main" id="{E4C421E2-E762-7090-39EA-AC5F843639E2}"/>
               </a:ext>
             </a:extLst>
           </p:cNvPr>
@@ -1846,7 +1846,7 @@
           <p:cNvPr id="9" name="Slide Number Placeholder 8">
             <a:extLst>
               <a:ext uri="{FF2B5EF4-FFF2-40B4-BE49-F238E27FC236}">
-                <a16:creationId xmlns:a16="http://schemas.microsoft.com/office/drawing/2014/main" id="{EE771AFA-B09B-2B31-0879-8A9BFCCAD34B}"/>
+                <a16:creationId xmlns:a16="http://schemas.microsoft.com/office/drawing/2014/main" id="{EE5D90EC-B05B-4F18-9166-83FD838AC2DB}"/>
               </a:ext>
             </a:extLst>
           </p:cNvPr>
@@ -1862,7 +1862,7 @@
           <a:bodyPr/>
           <a:lstStyle/>
           <a:p>
-            <a:fld id="{8ED8B9E9-2D87-4FA9-AB16-BA1525BB403E}" type="slidenum">
+            <a:fld id="{51417EEE-D195-4768-ADC3-D10258B34F23}" type="slidenum">
               <a:rPr lang="en-US" smtClean="0"/>
               <a:t>‹#›</a:t>
             </a:fld>
@@ -1873,7 +1873,7 @@
     </p:spTree>
     <p:extLst>
       <p:ext uri="{BB962C8B-B14F-4D97-AF65-F5344CB8AC3E}">
-        <p14:creationId xmlns:p14="http://schemas.microsoft.com/office/powerpoint/2010/main" val="3955159053"/>
+        <p14:creationId xmlns:p14="http://schemas.microsoft.com/office/powerpoint/2010/main" val="3864055311"/>
       </p:ext>
     </p:extLst>
   </p:cSld>
@@ -1905,7 +1905,7 @@
           <p:cNvPr id="2" name="Title 1">
             <a:extLst>
               <a:ext uri="{FF2B5EF4-FFF2-40B4-BE49-F238E27FC236}">
-                <a16:creationId xmlns:a16="http://schemas.microsoft.com/office/drawing/2014/main" id="{86F4D5CE-FF2A-7A21-A656-85BC12639D59}"/>
+                <a16:creationId xmlns:a16="http://schemas.microsoft.com/office/drawing/2014/main" id="{4C0A0C43-FDB8-4D27-1402-DC28B3EF2012}"/>
               </a:ext>
             </a:extLst>
           </p:cNvPr>
@@ -1933,7 +1933,7 @@
           <p:cNvPr id="3" name="Date Placeholder 2">
             <a:extLst>
               <a:ext uri="{FF2B5EF4-FFF2-40B4-BE49-F238E27FC236}">
-                <a16:creationId xmlns:a16="http://schemas.microsoft.com/office/drawing/2014/main" id="{D6A2004D-8FF0-956B-2B4B-43314254488D}"/>
+                <a16:creationId xmlns:a16="http://schemas.microsoft.com/office/drawing/2014/main" id="{F06CD679-AAAB-2480-BDB9-1A94735A4AB9}"/>
               </a:ext>
             </a:extLst>
           </p:cNvPr>
@@ -1949,7 +1949,7 @@
           <a:bodyPr/>
           <a:lstStyle/>
           <a:p>
-            <a:fld id="{CEA65F65-8E5A-4520-9F6B-2B300F18C5FA}" type="datetimeFigureOut">
+            <a:fld id="{D0DC34CB-9D0C-46D2-AF83-D9E99F6E08AA}" type="datetimeFigureOut">
               <a:rPr lang="en-US" smtClean="0"/>
               <a:t>6/25/2026</a:t>
             </a:fld>
@@ -1962,7 +1962,7 @@
           <p:cNvPr id="4" name="Footer Placeholder 3">
             <a:extLst>
               <a:ext uri="{FF2B5EF4-FFF2-40B4-BE49-F238E27FC236}">
-                <a16:creationId xmlns:a16="http://schemas.microsoft.com/office/drawing/2014/main" id="{D01E3BC5-A545-F6AB-DBD1-88CBA7CE0005}"/>
+                <a16:creationId xmlns:a16="http://schemas.microsoft.com/office/drawing/2014/main" id="{4A5FC15C-D082-B200-0896-BD34F10C7C1F}"/>
               </a:ext>
             </a:extLst>
           </p:cNvPr>
@@ -1987,7 +1987,7 @@
           <p:cNvPr id="5" name="Slide Number Placeholder 4">
             <a:extLst>
               <a:ext uri="{FF2B5EF4-FFF2-40B4-BE49-F238E27FC236}">
-                <a16:creationId xmlns:a16="http://schemas.microsoft.com/office/drawing/2014/main" id="{3499EE52-386A-482D-B67B-9929FFFC0102}"/>
+                <a16:creationId xmlns:a16="http://schemas.microsoft.com/office/drawing/2014/main" id="{A2978CDE-1141-A1E0-8542-D60AE5DBAAE6}"/>
               </a:ext>
             </a:extLst>
           </p:cNvPr>
@@ -2003,7 +2003,7 @@
           <a:bodyPr/>
           <a:lstStyle/>
           <a:p>
-            <a:fld id="{8ED8B9E9-2D87-4FA9-AB16-BA1525BB403E}" type="slidenum">
+            <a:fld id="{51417EEE-D195-4768-ADC3-D10258B34F23}" type="slidenum">
               <a:rPr lang="en-US" smtClean="0"/>
               <a:t>‹#›</a:t>
             </a:fld>
@@ -2014,7 +2014,7 @@
     </p:spTree>
     <p:extLst>
       <p:ext uri="{BB962C8B-B14F-4D97-AF65-F5344CB8AC3E}">
-        <p14:creationId xmlns:p14="http://schemas.microsoft.com/office/powerpoint/2010/main" val="528447365"/>
+        <p14:creationId xmlns:p14="http://schemas.microsoft.com/office/powerpoint/2010/main" val="1884334829"/>
       </p:ext>
     </p:extLst>
   </p:cSld>
@@ -2046,7 +2046,7 @@
           <p:cNvPr id="2" name="Date Placeholder 1">
             <a:extLst>
               <a:ext uri="{FF2B5EF4-FFF2-40B4-BE49-F238E27FC236}">
-                <a16:creationId xmlns:a16="http://schemas.microsoft.com/office/drawing/2014/main" id="{361A1801-5D0A-D4D0-699A-612FC3D15674}"/>
+                <a16:creationId xmlns:a16="http://schemas.microsoft.com/office/drawing/2014/main" id="{E83D7248-D55B-D0C0-E91A-AADA6D4A27A5}"/>
               </a:ext>
             </a:extLst>
           </p:cNvPr>
@@ -2062,7 +2062,7 @@
           <a:bodyPr/>
           <a:lstStyle/>
           <a:p>
-            <a:fld id="{CEA65F65-8E5A-4520-9F6B-2B300F18C5FA}" type="datetimeFigureOut">
+            <a:fld id="{D0DC34CB-9D0C-46D2-AF83-D9E99F6E08AA}" type="datetimeFigureOut">
               <a:rPr lang="en-US" smtClean="0"/>
               <a:t>6/25/2026</a:t>
             </a:fld>
@@ -2075,7 +2075,7 @@
           <p:cNvPr id="3" name="Footer Placeholder 2">
             <a:extLst>
               <a:ext uri="{FF2B5EF4-FFF2-40B4-BE49-F238E27FC236}">
-                <a16:creationId xmlns:a16="http://schemas.microsoft.com/office/drawing/2014/main" id="{8CB71ABB-0141-C70C-6290-B915DE637414}"/>
+                <a16:creationId xmlns:a16="http://schemas.microsoft.com/office/drawing/2014/main" id="{187CDEDE-FA27-6624-C85C-101066A1B2E5}"/>
               </a:ext>
             </a:extLst>
           </p:cNvPr>
@@ -2100,7 +2100,7 @@
           <p:cNvPr id="4" name="Slide Number Placeholder 3">
             <a:extLst>
               <a:ext uri="{FF2B5EF4-FFF2-40B4-BE49-F238E27FC236}">
-                <a16:creationId xmlns:a16="http://schemas.microsoft.com/office/drawing/2014/main" id="{17A34070-1C6A-39EB-43AC-32A2B6627302}"/>
+                <a16:creationId xmlns:a16="http://schemas.microsoft.com/office/drawing/2014/main" id="{61865284-99A5-9C7F-C1F2-6AEFAF8C0451}"/>
               </a:ext>
             </a:extLst>
           </p:cNvPr>
@@ -2116,7 +2116,7 @@
           <a:bodyPr/>
           <a:lstStyle/>
           <a:p>
-            <a:fld id="{8ED8B9E9-2D87-4FA9-AB16-BA1525BB403E}" type="slidenum">
+            <a:fld id="{51417EEE-D195-4768-ADC3-D10258B34F23}" type="slidenum">
               <a:rPr lang="en-US" smtClean="0"/>
               <a:t>‹#›</a:t>
             </a:fld>
@@ -2127,7 +2127,7 @@
     </p:spTree>
     <p:extLst>
       <p:ext uri="{BB962C8B-B14F-4D97-AF65-F5344CB8AC3E}">
-        <p14:creationId xmlns:p14="http://schemas.microsoft.com/office/powerpoint/2010/main" val="306451595"/>
+        <p14:creationId xmlns:p14="http://schemas.microsoft.com/office/powerpoint/2010/main" val="2649421545"/>
       </p:ext>
     </p:extLst>
   </p:cSld>
@@ -2159,7 +2159,7 @@
           <p:cNvPr id="2" name="Title 1">
             <a:extLst>
               <a:ext uri="{FF2B5EF4-FFF2-40B4-BE49-F238E27FC236}">
-                <a16:creationId xmlns:a16="http://schemas.microsoft.com/office/drawing/2014/main" id="{A37E1F86-996A-03D6-2319-8048529CCE68}"/>
+                <a16:creationId xmlns:a16="http://schemas.microsoft.com/office/drawing/2014/main" id="{B07F78B3-51FB-E2C0-12C9-5415E4EB0A9D}"/>
               </a:ext>
             </a:extLst>
           </p:cNvPr>
@@ -2196,7 +2196,7 @@
           <p:cNvPr id="3" name="Content Placeholder 2">
             <a:extLst>
               <a:ext uri="{FF2B5EF4-FFF2-40B4-BE49-F238E27FC236}">
-                <a16:creationId xmlns:a16="http://schemas.microsoft.com/office/drawing/2014/main" id="{CE88F8BC-D1AE-E5AF-ECD3-82FC5A3821BB}"/>
+                <a16:creationId xmlns:a16="http://schemas.microsoft.com/office/drawing/2014/main" id="{5B560998-0C14-AE12-9572-437CEA856433}"/>
               </a:ext>
             </a:extLst>
           </p:cNvPr>
@@ -2286,7 +2286,7 @@
           <p:cNvPr id="4" name="Text Placeholder 3">
             <a:extLst>
               <a:ext uri="{FF2B5EF4-FFF2-40B4-BE49-F238E27FC236}">
-                <a16:creationId xmlns:a16="http://schemas.microsoft.com/office/drawing/2014/main" id="{8BBCA913-1570-C36C-BEDB-476957FF9298}"/>
+                <a16:creationId xmlns:a16="http://schemas.microsoft.com/office/drawing/2014/main" id="{4F144F50-EAC9-4DA6-38B9-C3160531B411}"/>
               </a:ext>
             </a:extLst>
           </p:cNvPr>
@@ -2357,7 +2357,7 @@
           <p:cNvPr id="5" name="Date Placeholder 4">
             <a:extLst>
               <a:ext uri="{FF2B5EF4-FFF2-40B4-BE49-F238E27FC236}">
-                <a16:creationId xmlns:a16="http://schemas.microsoft.com/office/drawing/2014/main" id="{DC6AABAF-0184-CFB4-DECE-3215776CA104}"/>
+                <a16:creationId xmlns:a16="http://schemas.microsoft.com/office/drawing/2014/main" id="{C60A125A-30E4-5AE3-507C-41583C170144}"/>
               </a:ext>
             </a:extLst>
           </p:cNvPr>
@@ -2373,7 +2373,7 @@
           <a:bodyPr/>
           <a:lstStyle/>
           <a:p>
-            <a:fld id="{CEA65F65-8E5A-4520-9F6B-2B300F18C5FA}" type="datetimeFigureOut">
+            <a:fld id="{D0DC34CB-9D0C-46D2-AF83-D9E99F6E08AA}" type="datetimeFigureOut">
               <a:rPr lang="en-US" smtClean="0"/>
               <a:t>6/25/2026</a:t>
             </a:fld>
@@ -2386,7 +2386,7 @@
           <p:cNvPr id="6" name="Footer Placeholder 5">
             <a:extLst>
               <a:ext uri="{FF2B5EF4-FFF2-40B4-BE49-F238E27FC236}">
-                <a16:creationId xmlns:a16="http://schemas.microsoft.com/office/drawing/2014/main" id="{48CFD938-267C-CFC3-5B03-50894327DD0F}"/>
+                <a16:creationId xmlns:a16="http://schemas.microsoft.com/office/drawing/2014/main" id="{24596C91-20D9-4387-E550-B6D53C7DC757}"/>
               </a:ext>
             </a:extLst>
           </p:cNvPr>
@@ -2411,7 +2411,7 @@
           <p:cNvPr id="7" name="Slide Number Placeholder 6">
             <a:extLst>
               <a:ext uri="{FF2B5EF4-FFF2-40B4-BE49-F238E27FC236}">
-                <a16:creationId xmlns:a16="http://schemas.microsoft.com/office/drawing/2014/main" id="{F22878E9-D82A-76FB-9442-06B6E7FA68B6}"/>
+                <a16:creationId xmlns:a16="http://schemas.microsoft.com/office/drawing/2014/main" id="{AD50CB05-03AD-65F3-7789-F49A0A1942B0}"/>
               </a:ext>
             </a:extLst>
           </p:cNvPr>
@@ -2427,7 +2427,7 @@
           <a:bodyPr/>
           <a:lstStyle/>
           <a:p>
-            <a:fld id="{8ED8B9E9-2D87-4FA9-AB16-BA1525BB403E}" type="slidenum">
+            <a:fld id="{51417EEE-D195-4768-ADC3-D10258B34F23}" type="slidenum">
               <a:rPr lang="en-US" smtClean="0"/>
               <a:t>‹#›</a:t>
             </a:fld>
@@ -2438,7 +2438,7 @@
     </p:spTree>
     <p:extLst>
       <p:ext uri="{BB962C8B-B14F-4D97-AF65-F5344CB8AC3E}">
-        <p14:creationId xmlns:p14="http://schemas.microsoft.com/office/powerpoint/2010/main" val="3420911085"/>
+        <p14:creationId xmlns:p14="http://schemas.microsoft.com/office/powerpoint/2010/main" val="649292060"/>
       </p:ext>
     </p:extLst>
   </p:cSld>
@@ -2470,7 +2470,7 @@
           <p:cNvPr id="2" name="Title 1">
             <a:extLst>
               <a:ext uri="{FF2B5EF4-FFF2-40B4-BE49-F238E27FC236}">
-                <a16:creationId xmlns:a16="http://schemas.microsoft.com/office/drawing/2014/main" id="{F8CDD4AB-9171-55A2-2069-39B4358421DE}"/>
+                <a16:creationId xmlns:a16="http://schemas.microsoft.com/office/drawing/2014/main" id="{0538D3AA-139A-EDB5-A2C6-3C34A59CED2E}"/>
               </a:ext>
             </a:extLst>
           </p:cNvPr>
@@ -2507,7 +2507,7 @@
           <p:cNvPr id="3" name="Picture Placeholder 2">
             <a:extLst>
               <a:ext uri="{FF2B5EF4-FFF2-40B4-BE49-F238E27FC236}">
-                <a16:creationId xmlns:a16="http://schemas.microsoft.com/office/drawing/2014/main" id="{4C09455E-075C-FC7B-41B7-554F9D1B16C6}"/>
+                <a16:creationId xmlns:a16="http://schemas.microsoft.com/office/drawing/2014/main" id="{26519295-6FB5-EB01-E341-8B978A1D28B0}"/>
               </a:ext>
             </a:extLst>
           </p:cNvPr>
@@ -2574,7 +2574,7 @@
           <p:cNvPr id="4" name="Text Placeholder 3">
             <a:extLst>
               <a:ext uri="{FF2B5EF4-FFF2-40B4-BE49-F238E27FC236}">
-                <a16:creationId xmlns:a16="http://schemas.microsoft.com/office/drawing/2014/main" id="{849D414F-4DEE-E6AF-E9B5-363478B18B79}"/>
+                <a16:creationId xmlns:a16="http://schemas.microsoft.com/office/drawing/2014/main" id="{1A4DBF1C-5273-D9C1-CE29-157B961B9246}"/>
               </a:ext>
             </a:extLst>
           </p:cNvPr>
@@ -2645,7 +2645,7 @@
           <p:cNvPr id="5" name="Date Placeholder 4">
             <a:extLst>
               <a:ext uri="{FF2B5EF4-FFF2-40B4-BE49-F238E27FC236}">
-                <a16:creationId xmlns:a16="http://schemas.microsoft.com/office/drawing/2014/main" id="{74F1F9EB-929A-9506-92E0-057C52F4C8A8}"/>
+                <a16:creationId xmlns:a16="http://schemas.microsoft.com/office/drawing/2014/main" id="{58CA18AB-ACB9-B966-93DC-E43A39068403}"/>
               </a:ext>
             </a:extLst>
           </p:cNvPr>
@@ -2661,7 +2661,7 @@
           <a:bodyPr/>
           <a:lstStyle/>
           <a:p>
-            <a:fld id="{CEA65F65-8E5A-4520-9F6B-2B300F18C5FA}" type="datetimeFigureOut">
+            <a:fld id="{D0DC34CB-9D0C-46D2-AF83-D9E99F6E08AA}" type="datetimeFigureOut">
               <a:rPr lang="en-US" smtClean="0"/>
               <a:t>6/25/2026</a:t>
             </a:fld>
@@ -2674,7 +2674,7 @@
           <p:cNvPr id="6" name="Footer Placeholder 5">
             <a:extLst>
               <a:ext uri="{FF2B5EF4-FFF2-40B4-BE49-F238E27FC236}">
-                <a16:creationId xmlns:a16="http://schemas.microsoft.com/office/drawing/2014/main" id="{D48CB43F-64ED-CB3F-DDCF-E7AEDB0D84A1}"/>
+                <a16:creationId xmlns:a16="http://schemas.microsoft.com/office/drawing/2014/main" id="{5F825CAE-8664-091F-9E07-5ED468D6AEC0}"/>
               </a:ext>
             </a:extLst>
           </p:cNvPr>
@@ -2699,7 +2699,7 @@
           <p:cNvPr id="7" name="Slide Number Placeholder 6">
             <a:extLst>
               <a:ext uri="{FF2B5EF4-FFF2-40B4-BE49-F238E27FC236}">
-                <a16:creationId xmlns:a16="http://schemas.microsoft.com/office/drawing/2014/main" id="{1A7CC8F6-354B-EE79-0940-E9413294FC48}"/>
+                <a16:creationId xmlns:a16="http://schemas.microsoft.com/office/drawing/2014/main" id="{828CA7A8-B062-D114-9D3A-0C311EA0AC8C}"/>
               </a:ext>
             </a:extLst>
           </p:cNvPr>
@@ -2715,7 +2715,7 @@
           <a:bodyPr/>
           <a:lstStyle/>
           <a:p>
-            <a:fld id="{8ED8B9E9-2D87-4FA9-AB16-BA1525BB403E}" type="slidenum">
+            <a:fld id="{51417EEE-D195-4768-ADC3-D10258B34F23}" type="slidenum">
               <a:rPr lang="en-US" smtClean="0"/>
               <a:t>‹#›</a:t>
             </a:fld>
@@ -2726,7 +2726,7 @@
     </p:spTree>
     <p:extLst>
       <p:ext uri="{BB962C8B-B14F-4D97-AF65-F5344CB8AC3E}">
-        <p14:creationId xmlns:p14="http://schemas.microsoft.com/office/powerpoint/2010/main" val="52518325"/>
+        <p14:creationId xmlns:p14="http://schemas.microsoft.com/office/powerpoint/2010/main" val="2603647658"/>
       </p:ext>
     </p:extLst>
   </p:cSld>
@@ -2763,7 +2763,7 @@
           <p:cNvPr id="2" name="Title Placeholder 1">
             <a:extLst>
               <a:ext uri="{FF2B5EF4-FFF2-40B4-BE49-F238E27FC236}">
-                <a16:creationId xmlns:a16="http://schemas.microsoft.com/office/drawing/2014/main" id="{A14D229E-5EB3-0DEA-3243-311F8EDF8AB4}"/>
+                <a16:creationId xmlns:a16="http://schemas.microsoft.com/office/drawing/2014/main" id="{52DC1AB9-C607-56B4-75CF-0659531FC8EF}"/>
               </a:ext>
             </a:extLst>
           </p:cNvPr>
@@ -2801,7 +2801,7 @@
           <p:cNvPr id="3" name="Text Placeholder 2">
             <a:extLst>
               <a:ext uri="{FF2B5EF4-FFF2-40B4-BE49-F238E27FC236}">
-                <a16:creationId xmlns:a16="http://schemas.microsoft.com/office/drawing/2014/main" id="{E65C1C9F-869D-8429-36FC-F8B9AEB683D8}"/>
+                <a16:creationId xmlns:a16="http://schemas.microsoft.com/office/drawing/2014/main" id="{867F611B-6D07-E18C-AE83-194A0563CCD5}"/>
               </a:ext>
             </a:extLst>
           </p:cNvPr>
@@ -2868,7 +2868,7 @@
           <p:cNvPr id="4" name="Date Placeholder 3">
             <a:extLst>
               <a:ext uri="{FF2B5EF4-FFF2-40B4-BE49-F238E27FC236}">
-                <a16:creationId xmlns:a16="http://schemas.microsoft.com/office/drawing/2014/main" id="{C349DD78-97EC-4E05-D257-AB1EA4A61567}"/>
+                <a16:creationId xmlns:a16="http://schemas.microsoft.com/office/drawing/2014/main" id="{A58D2571-978A-1C45-6FCF-8DE1A8614867}"/>
               </a:ext>
             </a:extLst>
           </p:cNvPr>
@@ -2902,7 +2902,7 @@
             </a:lvl1pPr>
           </a:lstStyle>
           <a:p>
-            <a:fld id="{CEA65F65-8E5A-4520-9F6B-2B300F18C5FA}" type="datetimeFigureOut">
+            <a:fld id="{D0DC34CB-9D0C-46D2-AF83-D9E99F6E08AA}" type="datetimeFigureOut">
               <a:rPr lang="en-US" smtClean="0"/>
               <a:t>6/25/2026</a:t>
             </a:fld>
@@ -2915,7 +2915,7 @@
           <p:cNvPr id="5" name="Footer Placeholder 4">
             <a:extLst>
               <a:ext uri="{FF2B5EF4-FFF2-40B4-BE49-F238E27FC236}">
-                <a16:creationId xmlns:a16="http://schemas.microsoft.com/office/drawing/2014/main" id="{F3979987-2ED3-49ED-00FD-8E002EC0783D}"/>
+                <a16:creationId xmlns:a16="http://schemas.microsoft.com/office/drawing/2014/main" id="{09EDCFA3-95A7-E680-6269-D482703F130B}"/>
               </a:ext>
             </a:extLst>
           </p:cNvPr>
@@ -2958,7 +2958,7 @@
           <p:cNvPr id="6" name="Slide Number Placeholder 5">
             <a:extLst>
               <a:ext uri="{FF2B5EF4-FFF2-40B4-BE49-F238E27FC236}">
-                <a16:creationId xmlns:a16="http://schemas.microsoft.com/office/drawing/2014/main" id="{025D6B31-2408-83AA-CB71-37D2CD640FE9}"/>
+                <a16:creationId xmlns:a16="http://schemas.microsoft.com/office/drawing/2014/main" id="{08204ECA-15C0-A8C5-071C-261FF337E6E5}"/>
               </a:ext>
             </a:extLst>
           </p:cNvPr>
@@ -2992,7 +2992,7 @@
             </a:lvl1pPr>
           </a:lstStyle>
           <a:p>
-            <a:fld id="{8ED8B9E9-2D87-4FA9-AB16-BA1525BB403E}" type="slidenum">
+            <a:fld id="{51417EEE-D195-4768-ADC3-D10258B34F23}" type="slidenum">
               <a:rPr lang="en-US" smtClean="0"/>
               <a:t>‹#›</a:t>
             </a:fld>
@@ -3003,7 +3003,7 @@
     </p:spTree>
     <p:extLst>
       <p:ext uri="{BB962C8B-B14F-4D97-AF65-F5344CB8AC3E}">
-        <p14:creationId xmlns:p14="http://schemas.microsoft.com/office/powerpoint/2010/main" val="3790408266"/>
+        <p14:creationId xmlns:p14="http://schemas.microsoft.com/office/powerpoint/2010/main" val="2108118689"/>
       </p:ext>
     </p:extLst>
   </p:cSld>
@@ -3326,7 +3326,7 @@
           <p:cNvPr id="2" name="Title 1">
             <a:extLst>
               <a:ext uri="{FF2B5EF4-FFF2-40B4-BE49-F238E27FC236}">
-                <a16:creationId xmlns:a16="http://schemas.microsoft.com/office/drawing/2014/main" id="{4B18551A-E032-2482-0AB4-5D319D60A326}"/>
+                <a16:creationId xmlns:a16="http://schemas.microsoft.com/office/drawing/2014/main" id="{8166A849-2DDC-E3D7-73B4-BE8944B1CCF5}"/>
               </a:ext>
             </a:extLst>
           </p:cNvPr>
@@ -3356,7 +3356,7 @@
           <p:cNvPr id="3" name="Subtitle 2">
             <a:extLst>
               <a:ext uri="{FF2B5EF4-FFF2-40B4-BE49-F238E27FC236}">
-                <a16:creationId xmlns:a16="http://schemas.microsoft.com/office/drawing/2014/main" id="{FC18E707-D39F-D108-DDC9-D6FF4E98741A}"/>
+                <a16:creationId xmlns:a16="http://schemas.microsoft.com/office/drawing/2014/main" id="{6DE81D83-7CB8-24F0-AA16-08F63761F1E9}"/>
               </a:ext>
             </a:extLst>
           </p:cNvPr>
@@ -3384,7 +3384,7 @@
     </p:spTree>
     <p:extLst>
       <p:ext uri="{BB962C8B-B14F-4D97-AF65-F5344CB8AC3E}">
-        <p14:creationId xmlns:p14="http://schemas.microsoft.com/office/powerpoint/2010/main" val="175142171"/>
+        <p14:creationId xmlns:p14="http://schemas.microsoft.com/office/powerpoint/2010/main" val="3304708087"/>
       </p:ext>
     </p:extLst>
   </p:cSld>

</xml_diff>

<commit_message>
feat(freep/2c): regenerate corpus — add 06-charts.pptx (2D chart types), refresh all decks
- 06-charts.pptx: new corpus deck (slide-01 xlColumnClustered=51, slide-04 xlBarClustered=57)
  Previously slide-01 was xl3DColumn=-4100 causing artificial 3D-projection mismatch.
  Previously slide-04 was mislabeled; now correct 2D clustered bar type.
- 01–05 pptx: refreshed from CorpusGenerator (minor zip metadata updates, no content change)

Co-Authored-By: Claude Opus 4.8 <noreply@anthropic.com>
</commit_message>
<xml_diff>
--- a/tools/FreeP.RenderCompare/corpus/01-title-slide.pptx
+++ b/tools/FreeP.RenderCompare/corpus/01-title-slide.pptx
@@ -129,7 +129,7 @@
           <p:cNvPr id="2" name="Title 1">
             <a:extLst>
               <a:ext uri="{FF2B5EF4-FFF2-40B4-BE49-F238E27FC236}">
-                <a16:creationId xmlns:a16="http://schemas.microsoft.com/office/drawing/2014/main" id="{A126DF29-B1FF-008B-7EC8-3D3A78F563EF}"/>
+                <a16:creationId xmlns:a16="http://schemas.microsoft.com/office/drawing/2014/main" id="{46A67694-1CC0-C003-1E4E-ED236B2269DF}"/>
               </a:ext>
             </a:extLst>
           </p:cNvPr>
@@ -166,7 +166,7 @@
           <p:cNvPr id="3" name="Subtitle 2">
             <a:extLst>
               <a:ext uri="{FF2B5EF4-FFF2-40B4-BE49-F238E27FC236}">
-                <a16:creationId xmlns:a16="http://schemas.microsoft.com/office/drawing/2014/main" id="{35F67562-2779-69A0-1330-0094BDD6B0A9}"/>
+                <a16:creationId xmlns:a16="http://schemas.microsoft.com/office/drawing/2014/main" id="{BD71AB08-3AF3-DB6F-3AB2-D4F433E0ED89}"/>
               </a:ext>
             </a:extLst>
           </p:cNvPr>
@@ -236,7 +236,7 @@
           <p:cNvPr id="4" name="Date Placeholder 3">
             <a:extLst>
               <a:ext uri="{FF2B5EF4-FFF2-40B4-BE49-F238E27FC236}">
-                <a16:creationId xmlns:a16="http://schemas.microsoft.com/office/drawing/2014/main" id="{08CFAD3A-CCC8-EF7B-4B62-FDBAAC1CDC87}"/>
+                <a16:creationId xmlns:a16="http://schemas.microsoft.com/office/drawing/2014/main" id="{391BAFDF-B2E3-3CF0-9073-83E8F3C75CE4}"/>
               </a:ext>
             </a:extLst>
           </p:cNvPr>
@@ -252,7 +252,7 @@
           <a:bodyPr/>
           <a:lstStyle/>
           <a:p>
-            <a:fld id="{D0DC34CB-9D0C-46D2-AF83-D9E99F6E08AA}" type="datetimeFigureOut">
+            <a:fld id="{DFA09FBC-30DC-48BE-8530-D6CD85F75D45}" type="datetimeFigureOut">
               <a:rPr lang="en-US" smtClean="0"/>
               <a:t>6/25/2026</a:t>
             </a:fld>
@@ -265,7 +265,7 @@
           <p:cNvPr id="5" name="Footer Placeholder 4">
             <a:extLst>
               <a:ext uri="{FF2B5EF4-FFF2-40B4-BE49-F238E27FC236}">
-                <a16:creationId xmlns:a16="http://schemas.microsoft.com/office/drawing/2014/main" id="{34EEBD82-30B7-740B-773C-08ED3C41A576}"/>
+                <a16:creationId xmlns:a16="http://schemas.microsoft.com/office/drawing/2014/main" id="{9C7DF908-A66F-A521-848E-277A3095B2ED}"/>
               </a:ext>
             </a:extLst>
           </p:cNvPr>
@@ -290,7 +290,7 @@
           <p:cNvPr id="6" name="Slide Number Placeholder 5">
             <a:extLst>
               <a:ext uri="{FF2B5EF4-FFF2-40B4-BE49-F238E27FC236}">
-                <a16:creationId xmlns:a16="http://schemas.microsoft.com/office/drawing/2014/main" id="{6E389BAF-C914-908D-5DDD-8AC913451EE0}"/>
+                <a16:creationId xmlns:a16="http://schemas.microsoft.com/office/drawing/2014/main" id="{1781CAF9-3D40-1EBA-7757-EF932A1E2678}"/>
               </a:ext>
             </a:extLst>
           </p:cNvPr>
@@ -306,7 +306,7 @@
           <a:bodyPr/>
           <a:lstStyle/>
           <a:p>
-            <a:fld id="{51417EEE-D195-4768-ADC3-D10258B34F23}" type="slidenum">
+            <a:fld id="{69A9D669-6F5B-41F0-8144-61566721581D}" type="slidenum">
               <a:rPr lang="en-US" smtClean="0"/>
               <a:t>‹#›</a:t>
             </a:fld>
@@ -317,7 +317,7 @@
     </p:spTree>
     <p:extLst>
       <p:ext uri="{BB962C8B-B14F-4D97-AF65-F5344CB8AC3E}">
-        <p14:creationId xmlns:p14="http://schemas.microsoft.com/office/powerpoint/2010/main" val="2023766383"/>
+        <p14:creationId xmlns:p14="http://schemas.microsoft.com/office/powerpoint/2010/main" val="2786701469"/>
       </p:ext>
     </p:extLst>
   </p:cSld>
@@ -349,7 +349,7 @@
           <p:cNvPr id="2" name="Title 1">
             <a:extLst>
               <a:ext uri="{FF2B5EF4-FFF2-40B4-BE49-F238E27FC236}">
-                <a16:creationId xmlns:a16="http://schemas.microsoft.com/office/drawing/2014/main" id="{186F7801-93A4-9CE9-8AD9-66E1894DD856}"/>
+                <a16:creationId xmlns:a16="http://schemas.microsoft.com/office/drawing/2014/main" id="{2B559070-E62F-13A5-CB52-48A0E4F06FDE}"/>
               </a:ext>
             </a:extLst>
           </p:cNvPr>
@@ -377,7 +377,7 @@
           <p:cNvPr id="3" name="Vertical Text Placeholder 2">
             <a:extLst>
               <a:ext uri="{FF2B5EF4-FFF2-40B4-BE49-F238E27FC236}">
-                <a16:creationId xmlns:a16="http://schemas.microsoft.com/office/drawing/2014/main" id="{61C1A588-52B4-31C0-B55A-76A2E8A691AA}"/>
+                <a16:creationId xmlns:a16="http://schemas.microsoft.com/office/drawing/2014/main" id="{AE420098-9A49-ED49-1D4A-AE25B8B63C9D}"/>
               </a:ext>
             </a:extLst>
           </p:cNvPr>
@@ -434,7 +434,7 @@
           <p:cNvPr id="4" name="Date Placeholder 3">
             <a:extLst>
               <a:ext uri="{FF2B5EF4-FFF2-40B4-BE49-F238E27FC236}">
-                <a16:creationId xmlns:a16="http://schemas.microsoft.com/office/drawing/2014/main" id="{326E43AC-DE41-99D4-59CA-9CC7343F7F1A}"/>
+                <a16:creationId xmlns:a16="http://schemas.microsoft.com/office/drawing/2014/main" id="{0D5ACE03-2470-075A-D716-B1B9D2CF6CE9}"/>
               </a:ext>
             </a:extLst>
           </p:cNvPr>
@@ -450,7 +450,7 @@
           <a:bodyPr/>
           <a:lstStyle/>
           <a:p>
-            <a:fld id="{D0DC34CB-9D0C-46D2-AF83-D9E99F6E08AA}" type="datetimeFigureOut">
+            <a:fld id="{DFA09FBC-30DC-48BE-8530-D6CD85F75D45}" type="datetimeFigureOut">
               <a:rPr lang="en-US" smtClean="0"/>
               <a:t>6/25/2026</a:t>
             </a:fld>
@@ -463,7 +463,7 @@
           <p:cNvPr id="5" name="Footer Placeholder 4">
             <a:extLst>
               <a:ext uri="{FF2B5EF4-FFF2-40B4-BE49-F238E27FC236}">
-                <a16:creationId xmlns:a16="http://schemas.microsoft.com/office/drawing/2014/main" id="{DE42D85F-89DD-519D-D3EB-921ADB975EB4}"/>
+                <a16:creationId xmlns:a16="http://schemas.microsoft.com/office/drawing/2014/main" id="{CFECD791-B351-8C20-045A-C5BDE9844C18}"/>
               </a:ext>
             </a:extLst>
           </p:cNvPr>
@@ -488,7 +488,7 @@
           <p:cNvPr id="6" name="Slide Number Placeholder 5">
             <a:extLst>
               <a:ext uri="{FF2B5EF4-FFF2-40B4-BE49-F238E27FC236}">
-                <a16:creationId xmlns:a16="http://schemas.microsoft.com/office/drawing/2014/main" id="{104D729A-13FB-AC39-0859-C33F995B5D19}"/>
+                <a16:creationId xmlns:a16="http://schemas.microsoft.com/office/drawing/2014/main" id="{6507EEF0-F54E-1794-48FF-62CDC86BCE33}"/>
               </a:ext>
             </a:extLst>
           </p:cNvPr>
@@ -504,7 +504,7 @@
           <a:bodyPr/>
           <a:lstStyle/>
           <a:p>
-            <a:fld id="{51417EEE-D195-4768-ADC3-D10258B34F23}" type="slidenum">
+            <a:fld id="{69A9D669-6F5B-41F0-8144-61566721581D}" type="slidenum">
               <a:rPr lang="en-US" smtClean="0"/>
               <a:t>‹#›</a:t>
             </a:fld>
@@ -515,7 +515,7 @@
     </p:spTree>
     <p:extLst>
       <p:ext uri="{BB962C8B-B14F-4D97-AF65-F5344CB8AC3E}">
-        <p14:creationId xmlns:p14="http://schemas.microsoft.com/office/powerpoint/2010/main" val="1854278570"/>
+        <p14:creationId xmlns:p14="http://schemas.microsoft.com/office/powerpoint/2010/main" val="176025288"/>
       </p:ext>
     </p:extLst>
   </p:cSld>
@@ -547,7 +547,7 @@
           <p:cNvPr id="2" name="Vertical Title 1">
             <a:extLst>
               <a:ext uri="{FF2B5EF4-FFF2-40B4-BE49-F238E27FC236}">
-                <a16:creationId xmlns:a16="http://schemas.microsoft.com/office/drawing/2014/main" id="{F1CFEF52-0623-553F-0CF5-8F52DB8F1912}"/>
+                <a16:creationId xmlns:a16="http://schemas.microsoft.com/office/drawing/2014/main" id="{DB03D7E4-D985-4663-BB9C-48DBAEBA0910}"/>
               </a:ext>
             </a:extLst>
           </p:cNvPr>
@@ -580,7 +580,7 @@
           <p:cNvPr id="3" name="Vertical Text Placeholder 2">
             <a:extLst>
               <a:ext uri="{FF2B5EF4-FFF2-40B4-BE49-F238E27FC236}">
-                <a16:creationId xmlns:a16="http://schemas.microsoft.com/office/drawing/2014/main" id="{6E07F1D8-274D-1985-778B-ADE64AE580FA}"/>
+                <a16:creationId xmlns:a16="http://schemas.microsoft.com/office/drawing/2014/main" id="{4FF3F1D6-9C33-5752-DD11-F149E786320D}"/>
               </a:ext>
             </a:extLst>
           </p:cNvPr>
@@ -642,7 +642,7 @@
           <p:cNvPr id="4" name="Date Placeholder 3">
             <a:extLst>
               <a:ext uri="{FF2B5EF4-FFF2-40B4-BE49-F238E27FC236}">
-                <a16:creationId xmlns:a16="http://schemas.microsoft.com/office/drawing/2014/main" id="{019B3D65-CE55-773A-123D-335A9846802F}"/>
+                <a16:creationId xmlns:a16="http://schemas.microsoft.com/office/drawing/2014/main" id="{58A7B7FB-BEEC-4FA2-EE47-7EF94864D270}"/>
               </a:ext>
             </a:extLst>
           </p:cNvPr>
@@ -658,7 +658,7 @@
           <a:bodyPr/>
           <a:lstStyle/>
           <a:p>
-            <a:fld id="{D0DC34CB-9D0C-46D2-AF83-D9E99F6E08AA}" type="datetimeFigureOut">
+            <a:fld id="{DFA09FBC-30DC-48BE-8530-D6CD85F75D45}" type="datetimeFigureOut">
               <a:rPr lang="en-US" smtClean="0"/>
               <a:t>6/25/2026</a:t>
             </a:fld>
@@ -671,7 +671,7 @@
           <p:cNvPr id="5" name="Footer Placeholder 4">
             <a:extLst>
               <a:ext uri="{FF2B5EF4-FFF2-40B4-BE49-F238E27FC236}">
-                <a16:creationId xmlns:a16="http://schemas.microsoft.com/office/drawing/2014/main" id="{E32AD37B-5926-BB1E-D301-A5D96E42FC49}"/>
+                <a16:creationId xmlns:a16="http://schemas.microsoft.com/office/drawing/2014/main" id="{6B078AD5-945C-4C95-9853-9160C73A2418}"/>
               </a:ext>
             </a:extLst>
           </p:cNvPr>
@@ -696,7 +696,7 @@
           <p:cNvPr id="6" name="Slide Number Placeholder 5">
             <a:extLst>
               <a:ext uri="{FF2B5EF4-FFF2-40B4-BE49-F238E27FC236}">
-                <a16:creationId xmlns:a16="http://schemas.microsoft.com/office/drawing/2014/main" id="{47F4A8BF-B59A-D1D1-C925-03C13BDD26C6}"/>
+                <a16:creationId xmlns:a16="http://schemas.microsoft.com/office/drawing/2014/main" id="{34E761FC-2E80-0140-25D3-7B7BC5A07472}"/>
               </a:ext>
             </a:extLst>
           </p:cNvPr>
@@ -712,7 +712,7 @@
           <a:bodyPr/>
           <a:lstStyle/>
           <a:p>
-            <a:fld id="{51417EEE-D195-4768-ADC3-D10258B34F23}" type="slidenum">
+            <a:fld id="{69A9D669-6F5B-41F0-8144-61566721581D}" type="slidenum">
               <a:rPr lang="en-US" smtClean="0"/>
               <a:t>‹#›</a:t>
             </a:fld>
@@ -723,7 +723,7 @@
     </p:spTree>
     <p:extLst>
       <p:ext uri="{BB962C8B-B14F-4D97-AF65-F5344CB8AC3E}">
-        <p14:creationId xmlns:p14="http://schemas.microsoft.com/office/powerpoint/2010/main" val="2353762714"/>
+        <p14:creationId xmlns:p14="http://schemas.microsoft.com/office/powerpoint/2010/main" val="2907214330"/>
       </p:ext>
     </p:extLst>
   </p:cSld>
@@ -755,7 +755,7 @@
           <p:cNvPr id="2" name="Title 1">
             <a:extLst>
               <a:ext uri="{FF2B5EF4-FFF2-40B4-BE49-F238E27FC236}">
-                <a16:creationId xmlns:a16="http://schemas.microsoft.com/office/drawing/2014/main" id="{E4E2AE3D-FBD6-BEA1-A4E2-7A9B878A57B1}"/>
+                <a16:creationId xmlns:a16="http://schemas.microsoft.com/office/drawing/2014/main" id="{B2858912-8F08-3E17-A93E-28B05AA4AE3B}"/>
               </a:ext>
             </a:extLst>
           </p:cNvPr>
@@ -783,7 +783,7 @@
           <p:cNvPr id="3" name="Content Placeholder 2">
             <a:extLst>
               <a:ext uri="{FF2B5EF4-FFF2-40B4-BE49-F238E27FC236}">
-                <a16:creationId xmlns:a16="http://schemas.microsoft.com/office/drawing/2014/main" id="{88904176-05B4-071C-2C70-B57E54ADAA48}"/>
+                <a16:creationId xmlns:a16="http://schemas.microsoft.com/office/drawing/2014/main" id="{5C32C149-FA94-1191-3E0E-55FEC83AC4DC}"/>
               </a:ext>
             </a:extLst>
           </p:cNvPr>
@@ -840,7 +840,7 @@
           <p:cNvPr id="4" name="Date Placeholder 3">
             <a:extLst>
               <a:ext uri="{FF2B5EF4-FFF2-40B4-BE49-F238E27FC236}">
-                <a16:creationId xmlns:a16="http://schemas.microsoft.com/office/drawing/2014/main" id="{B2757395-04ED-9729-701C-133174037C06}"/>
+                <a16:creationId xmlns:a16="http://schemas.microsoft.com/office/drawing/2014/main" id="{E77F6980-1779-C3FE-072C-1C46C6A417BF}"/>
               </a:ext>
             </a:extLst>
           </p:cNvPr>
@@ -856,7 +856,7 @@
           <a:bodyPr/>
           <a:lstStyle/>
           <a:p>
-            <a:fld id="{D0DC34CB-9D0C-46D2-AF83-D9E99F6E08AA}" type="datetimeFigureOut">
+            <a:fld id="{DFA09FBC-30DC-48BE-8530-D6CD85F75D45}" type="datetimeFigureOut">
               <a:rPr lang="en-US" smtClean="0"/>
               <a:t>6/25/2026</a:t>
             </a:fld>
@@ -869,7 +869,7 @@
           <p:cNvPr id="5" name="Footer Placeholder 4">
             <a:extLst>
               <a:ext uri="{FF2B5EF4-FFF2-40B4-BE49-F238E27FC236}">
-                <a16:creationId xmlns:a16="http://schemas.microsoft.com/office/drawing/2014/main" id="{6C283D45-0762-E4BA-9865-41DFF100EF91}"/>
+                <a16:creationId xmlns:a16="http://schemas.microsoft.com/office/drawing/2014/main" id="{D52FD724-F416-4D53-1C15-F86C2F23F678}"/>
               </a:ext>
             </a:extLst>
           </p:cNvPr>
@@ -894,7 +894,7 @@
           <p:cNvPr id="6" name="Slide Number Placeholder 5">
             <a:extLst>
               <a:ext uri="{FF2B5EF4-FFF2-40B4-BE49-F238E27FC236}">
-                <a16:creationId xmlns:a16="http://schemas.microsoft.com/office/drawing/2014/main" id="{4808E48F-2DF9-71FF-F9D4-348DC68F2D4E}"/>
+                <a16:creationId xmlns:a16="http://schemas.microsoft.com/office/drawing/2014/main" id="{C606177F-BBAE-6EB6-7D2A-CF15B4B4889B}"/>
               </a:ext>
             </a:extLst>
           </p:cNvPr>
@@ -910,7 +910,7 @@
           <a:bodyPr/>
           <a:lstStyle/>
           <a:p>
-            <a:fld id="{51417EEE-D195-4768-ADC3-D10258B34F23}" type="slidenum">
+            <a:fld id="{69A9D669-6F5B-41F0-8144-61566721581D}" type="slidenum">
               <a:rPr lang="en-US" smtClean="0"/>
               <a:t>‹#›</a:t>
             </a:fld>
@@ -921,7 +921,7 @@
     </p:spTree>
     <p:extLst>
       <p:ext uri="{BB962C8B-B14F-4D97-AF65-F5344CB8AC3E}">
-        <p14:creationId xmlns:p14="http://schemas.microsoft.com/office/powerpoint/2010/main" val="1220380307"/>
+        <p14:creationId xmlns:p14="http://schemas.microsoft.com/office/powerpoint/2010/main" val="3380224604"/>
       </p:ext>
     </p:extLst>
   </p:cSld>
@@ -953,7 +953,7 @@
           <p:cNvPr id="2" name="Title 1">
             <a:extLst>
               <a:ext uri="{FF2B5EF4-FFF2-40B4-BE49-F238E27FC236}">
-                <a16:creationId xmlns:a16="http://schemas.microsoft.com/office/drawing/2014/main" id="{5C277243-153D-35AD-D536-06D49EFCAB36}"/>
+                <a16:creationId xmlns:a16="http://schemas.microsoft.com/office/drawing/2014/main" id="{2342C4B2-0E9D-C37E-9613-4410E7E89ADD}"/>
               </a:ext>
             </a:extLst>
           </p:cNvPr>
@@ -990,7 +990,7 @@
           <p:cNvPr id="3" name="Text Placeholder 2">
             <a:extLst>
               <a:ext uri="{FF2B5EF4-FFF2-40B4-BE49-F238E27FC236}">
-                <a16:creationId xmlns:a16="http://schemas.microsoft.com/office/drawing/2014/main" id="{EFA6A44C-49FF-9476-2ADE-B1EC2CDD013F}"/>
+                <a16:creationId xmlns:a16="http://schemas.microsoft.com/office/drawing/2014/main" id="{45150BE7-A2CB-B91A-19CA-DF6544492112}"/>
               </a:ext>
             </a:extLst>
           </p:cNvPr>
@@ -1115,7 +1115,7 @@
           <p:cNvPr id="4" name="Date Placeholder 3">
             <a:extLst>
               <a:ext uri="{FF2B5EF4-FFF2-40B4-BE49-F238E27FC236}">
-                <a16:creationId xmlns:a16="http://schemas.microsoft.com/office/drawing/2014/main" id="{193353AA-5D9E-37E5-E663-719F7EE08587}"/>
+                <a16:creationId xmlns:a16="http://schemas.microsoft.com/office/drawing/2014/main" id="{13045FB9-E9C4-7FE3-0326-B2ADB4F4B327}"/>
               </a:ext>
             </a:extLst>
           </p:cNvPr>
@@ -1131,7 +1131,7 @@
           <a:bodyPr/>
           <a:lstStyle/>
           <a:p>
-            <a:fld id="{D0DC34CB-9D0C-46D2-AF83-D9E99F6E08AA}" type="datetimeFigureOut">
+            <a:fld id="{DFA09FBC-30DC-48BE-8530-D6CD85F75D45}" type="datetimeFigureOut">
               <a:rPr lang="en-US" smtClean="0"/>
               <a:t>6/25/2026</a:t>
             </a:fld>
@@ -1144,7 +1144,7 @@
           <p:cNvPr id="5" name="Footer Placeholder 4">
             <a:extLst>
               <a:ext uri="{FF2B5EF4-FFF2-40B4-BE49-F238E27FC236}">
-                <a16:creationId xmlns:a16="http://schemas.microsoft.com/office/drawing/2014/main" id="{645D1295-88CC-5EED-83CB-53E4F75D84E2}"/>
+                <a16:creationId xmlns:a16="http://schemas.microsoft.com/office/drawing/2014/main" id="{7E19391B-5745-827B-C43E-318A47F45819}"/>
               </a:ext>
             </a:extLst>
           </p:cNvPr>
@@ -1169,7 +1169,7 @@
           <p:cNvPr id="6" name="Slide Number Placeholder 5">
             <a:extLst>
               <a:ext uri="{FF2B5EF4-FFF2-40B4-BE49-F238E27FC236}">
-                <a16:creationId xmlns:a16="http://schemas.microsoft.com/office/drawing/2014/main" id="{E798EE99-055A-D476-F5EB-0C17E2E93467}"/>
+                <a16:creationId xmlns:a16="http://schemas.microsoft.com/office/drawing/2014/main" id="{C2DEA631-998D-A42C-278E-77FCED0CFE62}"/>
               </a:ext>
             </a:extLst>
           </p:cNvPr>
@@ -1185,7 +1185,7 @@
           <a:bodyPr/>
           <a:lstStyle/>
           <a:p>
-            <a:fld id="{51417EEE-D195-4768-ADC3-D10258B34F23}" type="slidenum">
+            <a:fld id="{69A9D669-6F5B-41F0-8144-61566721581D}" type="slidenum">
               <a:rPr lang="en-US" smtClean="0"/>
               <a:t>‹#›</a:t>
             </a:fld>
@@ -1196,7 +1196,7 @@
     </p:spTree>
     <p:extLst>
       <p:ext uri="{BB962C8B-B14F-4D97-AF65-F5344CB8AC3E}">
-        <p14:creationId xmlns:p14="http://schemas.microsoft.com/office/powerpoint/2010/main" val="1819538815"/>
+        <p14:creationId xmlns:p14="http://schemas.microsoft.com/office/powerpoint/2010/main" val="772151082"/>
       </p:ext>
     </p:extLst>
   </p:cSld>
@@ -1228,7 +1228,7 @@
           <p:cNvPr id="2" name="Title 1">
             <a:extLst>
               <a:ext uri="{FF2B5EF4-FFF2-40B4-BE49-F238E27FC236}">
-                <a16:creationId xmlns:a16="http://schemas.microsoft.com/office/drawing/2014/main" id="{76FD9A12-7847-12FC-631E-9B723D8F9C44}"/>
+                <a16:creationId xmlns:a16="http://schemas.microsoft.com/office/drawing/2014/main" id="{BC12A5E4-6040-F308-E144-AAC371C71900}"/>
               </a:ext>
             </a:extLst>
           </p:cNvPr>
@@ -1256,7 +1256,7 @@
           <p:cNvPr id="3" name="Content Placeholder 2">
             <a:extLst>
               <a:ext uri="{FF2B5EF4-FFF2-40B4-BE49-F238E27FC236}">
-                <a16:creationId xmlns:a16="http://schemas.microsoft.com/office/drawing/2014/main" id="{4983E0CB-9BBD-BEB4-AB91-61F68D1F172D}"/>
+                <a16:creationId xmlns:a16="http://schemas.microsoft.com/office/drawing/2014/main" id="{F92F4DC4-AF56-D51D-9E3C-51A430D27C81}"/>
               </a:ext>
             </a:extLst>
           </p:cNvPr>
@@ -1318,7 +1318,7 @@
           <p:cNvPr id="4" name="Content Placeholder 3">
             <a:extLst>
               <a:ext uri="{FF2B5EF4-FFF2-40B4-BE49-F238E27FC236}">
-                <a16:creationId xmlns:a16="http://schemas.microsoft.com/office/drawing/2014/main" id="{F608B959-0CC3-F652-0D16-DFEF901A8786}"/>
+                <a16:creationId xmlns:a16="http://schemas.microsoft.com/office/drawing/2014/main" id="{7A8641FC-F55C-A6F8-2361-3F9BB3DB350E}"/>
               </a:ext>
             </a:extLst>
           </p:cNvPr>
@@ -1380,7 +1380,7 @@
           <p:cNvPr id="5" name="Date Placeholder 4">
             <a:extLst>
               <a:ext uri="{FF2B5EF4-FFF2-40B4-BE49-F238E27FC236}">
-                <a16:creationId xmlns:a16="http://schemas.microsoft.com/office/drawing/2014/main" id="{7D09EBF0-DC90-3F90-A5AA-4E8B9F53D596}"/>
+                <a16:creationId xmlns:a16="http://schemas.microsoft.com/office/drawing/2014/main" id="{A36F0BC3-627F-6D17-E3E6-A4BFF4A6FF05}"/>
               </a:ext>
             </a:extLst>
           </p:cNvPr>
@@ -1396,7 +1396,7 @@
           <a:bodyPr/>
           <a:lstStyle/>
           <a:p>
-            <a:fld id="{D0DC34CB-9D0C-46D2-AF83-D9E99F6E08AA}" type="datetimeFigureOut">
+            <a:fld id="{DFA09FBC-30DC-48BE-8530-D6CD85F75D45}" type="datetimeFigureOut">
               <a:rPr lang="en-US" smtClean="0"/>
               <a:t>6/25/2026</a:t>
             </a:fld>
@@ -1409,7 +1409,7 @@
           <p:cNvPr id="6" name="Footer Placeholder 5">
             <a:extLst>
               <a:ext uri="{FF2B5EF4-FFF2-40B4-BE49-F238E27FC236}">
-                <a16:creationId xmlns:a16="http://schemas.microsoft.com/office/drawing/2014/main" id="{32FF2393-B89D-C221-A730-A4E226AD5B53}"/>
+                <a16:creationId xmlns:a16="http://schemas.microsoft.com/office/drawing/2014/main" id="{CD58825E-F9B3-A42A-2DA9-FFC8B617BA62}"/>
               </a:ext>
             </a:extLst>
           </p:cNvPr>
@@ -1434,7 +1434,7 @@
           <p:cNvPr id="7" name="Slide Number Placeholder 6">
             <a:extLst>
               <a:ext uri="{FF2B5EF4-FFF2-40B4-BE49-F238E27FC236}">
-                <a16:creationId xmlns:a16="http://schemas.microsoft.com/office/drawing/2014/main" id="{DC0B01AF-51C4-11BC-158A-E044D1735241}"/>
+                <a16:creationId xmlns:a16="http://schemas.microsoft.com/office/drawing/2014/main" id="{E231A3DF-2B66-3BCA-29ED-9DEBDEA2AFA3}"/>
               </a:ext>
             </a:extLst>
           </p:cNvPr>
@@ -1450,7 +1450,7 @@
           <a:bodyPr/>
           <a:lstStyle/>
           <a:p>
-            <a:fld id="{51417EEE-D195-4768-ADC3-D10258B34F23}" type="slidenum">
+            <a:fld id="{69A9D669-6F5B-41F0-8144-61566721581D}" type="slidenum">
               <a:rPr lang="en-US" smtClean="0"/>
               <a:t>‹#›</a:t>
             </a:fld>
@@ -1461,7 +1461,7 @@
     </p:spTree>
     <p:extLst>
       <p:ext uri="{BB962C8B-B14F-4D97-AF65-F5344CB8AC3E}">
-        <p14:creationId xmlns:p14="http://schemas.microsoft.com/office/powerpoint/2010/main" val="2755836416"/>
+        <p14:creationId xmlns:p14="http://schemas.microsoft.com/office/powerpoint/2010/main" val="2583676062"/>
       </p:ext>
     </p:extLst>
   </p:cSld>
@@ -1493,7 +1493,7 @@
           <p:cNvPr id="2" name="Title 1">
             <a:extLst>
               <a:ext uri="{FF2B5EF4-FFF2-40B4-BE49-F238E27FC236}">
-                <a16:creationId xmlns:a16="http://schemas.microsoft.com/office/drawing/2014/main" id="{E7FB6399-F249-65B2-CF98-876F586C9D14}"/>
+                <a16:creationId xmlns:a16="http://schemas.microsoft.com/office/drawing/2014/main" id="{7F34F8B4-1D32-AC6E-3397-D286F2F0E827}"/>
               </a:ext>
             </a:extLst>
           </p:cNvPr>
@@ -1526,7 +1526,7 @@
           <p:cNvPr id="3" name="Text Placeholder 2">
             <a:extLst>
               <a:ext uri="{FF2B5EF4-FFF2-40B4-BE49-F238E27FC236}">
-                <a16:creationId xmlns:a16="http://schemas.microsoft.com/office/drawing/2014/main" id="{42EAED86-FF78-E8D7-7E1E-C93D29D77950}"/>
+                <a16:creationId xmlns:a16="http://schemas.microsoft.com/office/drawing/2014/main" id="{527D9DA0-6DEA-5D17-11C9-EA313D745A05}"/>
               </a:ext>
             </a:extLst>
           </p:cNvPr>
@@ -1597,7 +1597,7 @@
           <p:cNvPr id="4" name="Content Placeholder 3">
             <a:extLst>
               <a:ext uri="{FF2B5EF4-FFF2-40B4-BE49-F238E27FC236}">
-                <a16:creationId xmlns:a16="http://schemas.microsoft.com/office/drawing/2014/main" id="{037EDCA0-0EB6-2E05-179C-52BBBC15804D}"/>
+                <a16:creationId xmlns:a16="http://schemas.microsoft.com/office/drawing/2014/main" id="{CD995310-AB54-078E-F812-F0EC2BD188C8}"/>
               </a:ext>
             </a:extLst>
           </p:cNvPr>
@@ -1659,7 +1659,7 @@
           <p:cNvPr id="5" name="Text Placeholder 4">
             <a:extLst>
               <a:ext uri="{FF2B5EF4-FFF2-40B4-BE49-F238E27FC236}">
-                <a16:creationId xmlns:a16="http://schemas.microsoft.com/office/drawing/2014/main" id="{E43A62CA-EF80-F6FE-4208-19EAEE28DF87}"/>
+                <a16:creationId xmlns:a16="http://schemas.microsoft.com/office/drawing/2014/main" id="{A6F7410B-9D66-4C95-1308-C42716ADADA8}"/>
               </a:ext>
             </a:extLst>
           </p:cNvPr>
@@ -1730,7 +1730,7 @@
           <p:cNvPr id="6" name="Content Placeholder 5">
             <a:extLst>
               <a:ext uri="{FF2B5EF4-FFF2-40B4-BE49-F238E27FC236}">
-                <a16:creationId xmlns:a16="http://schemas.microsoft.com/office/drawing/2014/main" id="{4894C1F4-0253-E62F-260E-C553A8562162}"/>
+                <a16:creationId xmlns:a16="http://schemas.microsoft.com/office/drawing/2014/main" id="{A237C342-FEA2-D1EB-F4F1-560E837DAF04}"/>
               </a:ext>
             </a:extLst>
           </p:cNvPr>
@@ -1792,7 +1792,7 @@
           <p:cNvPr id="7" name="Date Placeholder 6">
             <a:extLst>
               <a:ext uri="{FF2B5EF4-FFF2-40B4-BE49-F238E27FC236}">
-                <a16:creationId xmlns:a16="http://schemas.microsoft.com/office/drawing/2014/main" id="{602F7CF6-AC83-69B5-A37B-069FB899AF45}"/>
+                <a16:creationId xmlns:a16="http://schemas.microsoft.com/office/drawing/2014/main" id="{F690B6A9-002C-58CF-31CB-55E128FB5698}"/>
               </a:ext>
             </a:extLst>
           </p:cNvPr>
@@ -1808,7 +1808,7 @@
           <a:bodyPr/>
           <a:lstStyle/>
           <a:p>
-            <a:fld id="{D0DC34CB-9D0C-46D2-AF83-D9E99F6E08AA}" type="datetimeFigureOut">
+            <a:fld id="{DFA09FBC-30DC-48BE-8530-D6CD85F75D45}" type="datetimeFigureOut">
               <a:rPr lang="en-US" smtClean="0"/>
               <a:t>6/25/2026</a:t>
             </a:fld>
@@ -1821,7 +1821,7 @@
           <p:cNvPr id="8" name="Footer Placeholder 7">
             <a:extLst>
               <a:ext uri="{FF2B5EF4-FFF2-40B4-BE49-F238E27FC236}">
-                <a16:creationId xmlns:a16="http://schemas.microsoft.com/office/drawing/2014/main" id="{E4C421E2-E762-7090-39EA-AC5F843639E2}"/>
+                <a16:creationId xmlns:a16="http://schemas.microsoft.com/office/drawing/2014/main" id="{8EDBCD60-1D39-25E2-4AA5-DABF0181D73F}"/>
               </a:ext>
             </a:extLst>
           </p:cNvPr>
@@ -1846,7 +1846,7 @@
           <p:cNvPr id="9" name="Slide Number Placeholder 8">
             <a:extLst>
               <a:ext uri="{FF2B5EF4-FFF2-40B4-BE49-F238E27FC236}">
-                <a16:creationId xmlns:a16="http://schemas.microsoft.com/office/drawing/2014/main" id="{EE5D90EC-B05B-4F18-9166-83FD838AC2DB}"/>
+                <a16:creationId xmlns:a16="http://schemas.microsoft.com/office/drawing/2014/main" id="{C46E4CDA-87CB-2241-156D-837DDEC3B4EC}"/>
               </a:ext>
             </a:extLst>
           </p:cNvPr>
@@ -1862,7 +1862,7 @@
           <a:bodyPr/>
           <a:lstStyle/>
           <a:p>
-            <a:fld id="{51417EEE-D195-4768-ADC3-D10258B34F23}" type="slidenum">
+            <a:fld id="{69A9D669-6F5B-41F0-8144-61566721581D}" type="slidenum">
               <a:rPr lang="en-US" smtClean="0"/>
               <a:t>‹#›</a:t>
             </a:fld>
@@ -1873,7 +1873,7 @@
     </p:spTree>
     <p:extLst>
       <p:ext uri="{BB962C8B-B14F-4D97-AF65-F5344CB8AC3E}">
-        <p14:creationId xmlns:p14="http://schemas.microsoft.com/office/powerpoint/2010/main" val="3864055311"/>
+        <p14:creationId xmlns:p14="http://schemas.microsoft.com/office/powerpoint/2010/main" val="2839370475"/>
       </p:ext>
     </p:extLst>
   </p:cSld>
@@ -1905,7 +1905,7 @@
           <p:cNvPr id="2" name="Title 1">
             <a:extLst>
               <a:ext uri="{FF2B5EF4-FFF2-40B4-BE49-F238E27FC236}">
-                <a16:creationId xmlns:a16="http://schemas.microsoft.com/office/drawing/2014/main" id="{4C0A0C43-FDB8-4D27-1402-DC28B3EF2012}"/>
+                <a16:creationId xmlns:a16="http://schemas.microsoft.com/office/drawing/2014/main" id="{B3C70B61-CB3C-6244-0AC1-D3C487FF7103}"/>
               </a:ext>
             </a:extLst>
           </p:cNvPr>
@@ -1933,7 +1933,7 @@
           <p:cNvPr id="3" name="Date Placeholder 2">
             <a:extLst>
               <a:ext uri="{FF2B5EF4-FFF2-40B4-BE49-F238E27FC236}">
-                <a16:creationId xmlns:a16="http://schemas.microsoft.com/office/drawing/2014/main" id="{F06CD679-AAAB-2480-BDB9-1A94735A4AB9}"/>
+                <a16:creationId xmlns:a16="http://schemas.microsoft.com/office/drawing/2014/main" id="{D1277E42-D392-302A-79B5-7356811E106F}"/>
               </a:ext>
             </a:extLst>
           </p:cNvPr>
@@ -1949,7 +1949,7 @@
           <a:bodyPr/>
           <a:lstStyle/>
           <a:p>
-            <a:fld id="{D0DC34CB-9D0C-46D2-AF83-D9E99F6E08AA}" type="datetimeFigureOut">
+            <a:fld id="{DFA09FBC-30DC-48BE-8530-D6CD85F75D45}" type="datetimeFigureOut">
               <a:rPr lang="en-US" smtClean="0"/>
               <a:t>6/25/2026</a:t>
             </a:fld>
@@ -1962,7 +1962,7 @@
           <p:cNvPr id="4" name="Footer Placeholder 3">
             <a:extLst>
               <a:ext uri="{FF2B5EF4-FFF2-40B4-BE49-F238E27FC236}">
-                <a16:creationId xmlns:a16="http://schemas.microsoft.com/office/drawing/2014/main" id="{4A5FC15C-D082-B200-0896-BD34F10C7C1F}"/>
+                <a16:creationId xmlns:a16="http://schemas.microsoft.com/office/drawing/2014/main" id="{8074BD52-9A10-ED6E-5B9E-E685A5A3202D}"/>
               </a:ext>
             </a:extLst>
           </p:cNvPr>
@@ -1987,7 +1987,7 @@
           <p:cNvPr id="5" name="Slide Number Placeholder 4">
             <a:extLst>
               <a:ext uri="{FF2B5EF4-FFF2-40B4-BE49-F238E27FC236}">
-                <a16:creationId xmlns:a16="http://schemas.microsoft.com/office/drawing/2014/main" id="{A2978CDE-1141-A1E0-8542-D60AE5DBAAE6}"/>
+                <a16:creationId xmlns:a16="http://schemas.microsoft.com/office/drawing/2014/main" id="{9EE0EA3B-05E3-DBC8-D474-2F7B9BD0A12C}"/>
               </a:ext>
             </a:extLst>
           </p:cNvPr>
@@ -2003,7 +2003,7 @@
           <a:bodyPr/>
           <a:lstStyle/>
           <a:p>
-            <a:fld id="{51417EEE-D195-4768-ADC3-D10258B34F23}" type="slidenum">
+            <a:fld id="{69A9D669-6F5B-41F0-8144-61566721581D}" type="slidenum">
               <a:rPr lang="en-US" smtClean="0"/>
               <a:t>‹#›</a:t>
             </a:fld>
@@ -2014,7 +2014,7 @@
     </p:spTree>
     <p:extLst>
       <p:ext uri="{BB962C8B-B14F-4D97-AF65-F5344CB8AC3E}">
-        <p14:creationId xmlns:p14="http://schemas.microsoft.com/office/powerpoint/2010/main" val="1884334829"/>
+        <p14:creationId xmlns:p14="http://schemas.microsoft.com/office/powerpoint/2010/main" val="2903749447"/>
       </p:ext>
     </p:extLst>
   </p:cSld>
@@ -2046,7 +2046,7 @@
           <p:cNvPr id="2" name="Date Placeholder 1">
             <a:extLst>
               <a:ext uri="{FF2B5EF4-FFF2-40B4-BE49-F238E27FC236}">
-                <a16:creationId xmlns:a16="http://schemas.microsoft.com/office/drawing/2014/main" id="{E83D7248-D55B-D0C0-E91A-AADA6D4A27A5}"/>
+                <a16:creationId xmlns:a16="http://schemas.microsoft.com/office/drawing/2014/main" id="{9DF694DE-2D8D-D879-2FCE-A15C7FF7BDBA}"/>
               </a:ext>
             </a:extLst>
           </p:cNvPr>
@@ -2062,7 +2062,7 @@
           <a:bodyPr/>
           <a:lstStyle/>
           <a:p>
-            <a:fld id="{D0DC34CB-9D0C-46D2-AF83-D9E99F6E08AA}" type="datetimeFigureOut">
+            <a:fld id="{DFA09FBC-30DC-48BE-8530-D6CD85F75D45}" type="datetimeFigureOut">
               <a:rPr lang="en-US" smtClean="0"/>
               <a:t>6/25/2026</a:t>
             </a:fld>
@@ -2075,7 +2075,7 @@
           <p:cNvPr id="3" name="Footer Placeholder 2">
             <a:extLst>
               <a:ext uri="{FF2B5EF4-FFF2-40B4-BE49-F238E27FC236}">
-                <a16:creationId xmlns:a16="http://schemas.microsoft.com/office/drawing/2014/main" id="{187CDEDE-FA27-6624-C85C-101066A1B2E5}"/>
+                <a16:creationId xmlns:a16="http://schemas.microsoft.com/office/drawing/2014/main" id="{BDF3E405-237F-00CC-B6A5-0D6E78826DE9}"/>
               </a:ext>
             </a:extLst>
           </p:cNvPr>
@@ -2100,7 +2100,7 @@
           <p:cNvPr id="4" name="Slide Number Placeholder 3">
             <a:extLst>
               <a:ext uri="{FF2B5EF4-FFF2-40B4-BE49-F238E27FC236}">
-                <a16:creationId xmlns:a16="http://schemas.microsoft.com/office/drawing/2014/main" id="{61865284-99A5-9C7F-C1F2-6AEFAF8C0451}"/>
+                <a16:creationId xmlns:a16="http://schemas.microsoft.com/office/drawing/2014/main" id="{617D8E23-7625-7261-20CA-2099A78FB76E}"/>
               </a:ext>
             </a:extLst>
           </p:cNvPr>
@@ -2116,7 +2116,7 @@
           <a:bodyPr/>
           <a:lstStyle/>
           <a:p>
-            <a:fld id="{51417EEE-D195-4768-ADC3-D10258B34F23}" type="slidenum">
+            <a:fld id="{69A9D669-6F5B-41F0-8144-61566721581D}" type="slidenum">
               <a:rPr lang="en-US" smtClean="0"/>
               <a:t>‹#›</a:t>
             </a:fld>
@@ -2127,7 +2127,7 @@
     </p:spTree>
     <p:extLst>
       <p:ext uri="{BB962C8B-B14F-4D97-AF65-F5344CB8AC3E}">
-        <p14:creationId xmlns:p14="http://schemas.microsoft.com/office/powerpoint/2010/main" val="2649421545"/>
+        <p14:creationId xmlns:p14="http://schemas.microsoft.com/office/powerpoint/2010/main" val="3971640325"/>
       </p:ext>
     </p:extLst>
   </p:cSld>
@@ -2159,7 +2159,7 @@
           <p:cNvPr id="2" name="Title 1">
             <a:extLst>
               <a:ext uri="{FF2B5EF4-FFF2-40B4-BE49-F238E27FC236}">
-                <a16:creationId xmlns:a16="http://schemas.microsoft.com/office/drawing/2014/main" id="{B07F78B3-51FB-E2C0-12C9-5415E4EB0A9D}"/>
+                <a16:creationId xmlns:a16="http://schemas.microsoft.com/office/drawing/2014/main" id="{092BBAAB-C740-9C29-7CE3-EF06C42D0DCF}"/>
               </a:ext>
             </a:extLst>
           </p:cNvPr>
@@ -2196,7 +2196,7 @@
           <p:cNvPr id="3" name="Content Placeholder 2">
             <a:extLst>
               <a:ext uri="{FF2B5EF4-FFF2-40B4-BE49-F238E27FC236}">
-                <a16:creationId xmlns:a16="http://schemas.microsoft.com/office/drawing/2014/main" id="{5B560998-0C14-AE12-9572-437CEA856433}"/>
+                <a16:creationId xmlns:a16="http://schemas.microsoft.com/office/drawing/2014/main" id="{02F5C402-3A33-4293-7D6D-3749DB06363B}"/>
               </a:ext>
             </a:extLst>
           </p:cNvPr>
@@ -2286,7 +2286,7 @@
           <p:cNvPr id="4" name="Text Placeholder 3">
             <a:extLst>
               <a:ext uri="{FF2B5EF4-FFF2-40B4-BE49-F238E27FC236}">
-                <a16:creationId xmlns:a16="http://schemas.microsoft.com/office/drawing/2014/main" id="{4F144F50-EAC9-4DA6-38B9-C3160531B411}"/>
+                <a16:creationId xmlns:a16="http://schemas.microsoft.com/office/drawing/2014/main" id="{B2290B98-DC24-67EE-35D0-76AE7D744972}"/>
               </a:ext>
             </a:extLst>
           </p:cNvPr>
@@ -2357,7 +2357,7 @@
           <p:cNvPr id="5" name="Date Placeholder 4">
             <a:extLst>
               <a:ext uri="{FF2B5EF4-FFF2-40B4-BE49-F238E27FC236}">
-                <a16:creationId xmlns:a16="http://schemas.microsoft.com/office/drawing/2014/main" id="{C60A125A-30E4-5AE3-507C-41583C170144}"/>
+                <a16:creationId xmlns:a16="http://schemas.microsoft.com/office/drawing/2014/main" id="{BB37EC92-6E1F-8708-8319-8CE3B0CDBFB2}"/>
               </a:ext>
             </a:extLst>
           </p:cNvPr>
@@ -2373,7 +2373,7 @@
           <a:bodyPr/>
           <a:lstStyle/>
           <a:p>
-            <a:fld id="{D0DC34CB-9D0C-46D2-AF83-D9E99F6E08AA}" type="datetimeFigureOut">
+            <a:fld id="{DFA09FBC-30DC-48BE-8530-D6CD85F75D45}" type="datetimeFigureOut">
               <a:rPr lang="en-US" smtClean="0"/>
               <a:t>6/25/2026</a:t>
             </a:fld>
@@ -2386,7 +2386,7 @@
           <p:cNvPr id="6" name="Footer Placeholder 5">
             <a:extLst>
               <a:ext uri="{FF2B5EF4-FFF2-40B4-BE49-F238E27FC236}">
-                <a16:creationId xmlns:a16="http://schemas.microsoft.com/office/drawing/2014/main" id="{24596C91-20D9-4387-E550-B6D53C7DC757}"/>
+                <a16:creationId xmlns:a16="http://schemas.microsoft.com/office/drawing/2014/main" id="{EBD40BEA-576B-BE80-80DC-23D162048088}"/>
               </a:ext>
             </a:extLst>
           </p:cNvPr>
@@ -2411,7 +2411,7 @@
           <p:cNvPr id="7" name="Slide Number Placeholder 6">
             <a:extLst>
               <a:ext uri="{FF2B5EF4-FFF2-40B4-BE49-F238E27FC236}">
-                <a16:creationId xmlns:a16="http://schemas.microsoft.com/office/drawing/2014/main" id="{AD50CB05-03AD-65F3-7789-F49A0A1942B0}"/>
+                <a16:creationId xmlns:a16="http://schemas.microsoft.com/office/drawing/2014/main" id="{0FB0216D-BDA6-AAD1-E0B0-7DF7D9AD655F}"/>
               </a:ext>
             </a:extLst>
           </p:cNvPr>
@@ -2427,7 +2427,7 @@
           <a:bodyPr/>
           <a:lstStyle/>
           <a:p>
-            <a:fld id="{51417EEE-D195-4768-ADC3-D10258B34F23}" type="slidenum">
+            <a:fld id="{69A9D669-6F5B-41F0-8144-61566721581D}" type="slidenum">
               <a:rPr lang="en-US" smtClean="0"/>
               <a:t>‹#›</a:t>
             </a:fld>
@@ -2438,7 +2438,7 @@
     </p:spTree>
     <p:extLst>
       <p:ext uri="{BB962C8B-B14F-4D97-AF65-F5344CB8AC3E}">
-        <p14:creationId xmlns:p14="http://schemas.microsoft.com/office/powerpoint/2010/main" val="649292060"/>
+        <p14:creationId xmlns:p14="http://schemas.microsoft.com/office/powerpoint/2010/main" val="21006010"/>
       </p:ext>
     </p:extLst>
   </p:cSld>
@@ -2470,7 +2470,7 @@
           <p:cNvPr id="2" name="Title 1">
             <a:extLst>
               <a:ext uri="{FF2B5EF4-FFF2-40B4-BE49-F238E27FC236}">
-                <a16:creationId xmlns:a16="http://schemas.microsoft.com/office/drawing/2014/main" id="{0538D3AA-139A-EDB5-A2C6-3C34A59CED2E}"/>
+                <a16:creationId xmlns:a16="http://schemas.microsoft.com/office/drawing/2014/main" id="{A4A77FD9-558D-0100-3CA7-37AC5C8A80F2}"/>
               </a:ext>
             </a:extLst>
           </p:cNvPr>
@@ -2507,7 +2507,7 @@
           <p:cNvPr id="3" name="Picture Placeholder 2">
             <a:extLst>
               <a:ext uri="{FF2B5EF4-FFF2-40B4-BE49-F238E27FC236}">
-                <a16:creationId xmlns:a16="http://schemas.microsoft.com/office/drawing/2014/main" id="{26519295-6FB5-EB01-E341-8B978A1D28B0}"/>
+                <a16:creationId xmlns:a16="http://schemas.microsoft.com/office/drawing/2014/main" id="{A0CFB07D-4FD4-E333-077E-9D37D0383B73}"/>
               </a:ext>
             </a:extLst>
           </p:cNvPr>
@@ -2574,7 +2574,7 @@
           <p:cNvPr id="4" name="Text Placeholder 3">
             <a:extLst>
               <a:ext uri="{FF2B5EF4-FFF2-40B4-BE49-F238E27FC236}">
-                <a16:creationId xmlns:a16="http://schemas.microsoft.com/office/drawing/2014/main" id="{1A4DBF1C-5273-D9C1-CE29-157B961B9246}"/>
+                <a16:creationId xmlns:a16="http://schemas.microsoft.com/office/drawing/2014/main" id="{5F6FB45B-52B2-A024-9B25-000683959216}"/>
               </a:ext>
             </a:extLst>
           </p:cNvPr>
@@ -2645,7 +2645,7 @@
           <p:cNvPr id="5" name="Date Placeholder 4">
             <a:extLst>
               <a:ext uri="{FF2B5EF4-FFF2-40B4-BE49-F238E27FC236}">
-                <a16:creationId xmlns:a16="http://schemas.microsoft.com/office/drawing/2014/main" id="{58CA18AB-ACB9-B966-93DC-E43A39068403}"/>
+                <a16:creationId xmlns:a16="http://schemas.microsoft.com/office/drawing/2014/main" id="{ED0479AE-0597-FE7B-3923-794E25ADE7C1}"/>
               </a:ext>
             </a:extLst>
           </p:cNvPr>
@@ -2661,7 +2661,7 @@
           <a:bodyPr/>
           <a:lstStyle/>
           <a:p>
-            <a:fld id="{D0DC34CB-9D0C-46D2-AF83-D9E99F6E08AA}" type="datetimeFigureOut">
+            <a:fld id="{DFA09FBC-30DC-48BE-8530-D6CD85F75D45}" type="datetimeFigureOut">
               <a:rPr lang="en-US" smtClean="0"/>
               <a:t>6/25/2026</a:t>
             </a:fld>
@@ -2674,7 +2674,7 @@
           <p:cNvPr id="6" name="Footer Placeholder 5">
             <a:extLst>
               <a:ext uri="{FF2B5EF4-FFF2-40B4-BE49-F238E27FC236}">
-                <a16:creationId xmlns:a16="http://schemas.microsoft.com/office/drawing/2014/main" id="{5F825CAE-8664-091F-9E07-5ED468D6AEC0}"/>
+                <a16:creationId xmlns:a16="http://schemas.microsoft.com/office/drawing/2014/main" id="{EFB29B26-BB99-811A-1A93-BBEF8556DD2D}"/>
               </a:ext>
             </a:extLst>
           </p:cNvPr>
@@ -2699,7 +2699,7 @@
           <p:cNvPr id="7" name="Slide Number Placeholder 6">
             <a:extLst>
               <a:ext uri="{FF2B5EF4-FFF2-40B4-BE49-F238E27FC236}">
-                <a16:creationId xmlns:a16="http://schemas.microsoft.com/office/drawing/2014/main" id="{828CA7A8-B062-D114-9D3A-0C311EA0AC8C}"/>
+                <a16:creationId xmlns:a16="http://schemas.microsoft.com/office/drawing/2014/main" id="{ED8E0F56-4C4D-3035-66D5-3F9BD24FC401}"/>
               </a:ext>
             </a:extLst>
           </p:cNvPr>
@@ -2715,7 +2715,7 @@
           <a:bodyPr/>
           <a:lstStyle/>
           <a:p>
-            <a:fld id="{51417EEE-D195-4768-ADC3-D10258B34F23}" type="slidenum">
+            <a:fld id="{69A9D669-6F5B-41F0-8144-61566721581D}" type="slidenum">
               <a:rPr lang="en-US" smtClean="0"/>
               <a:t>‹#›</a:t>
             </a:fld>
@@ -2726,7 +2726,7 @@
     </p:spTree>
     <p:extLst>
       <p:ext uri="{BB962C8B-B14F-4D97-AF65-F5344CB8AC3E}">
-        <p14:creationId xmlns:p14="http://schemas.microsoft.com/office/powerpoint/2010/main" val="2603647658"/>
+        <p14:creationId xmlns:p14="http://schemas.microsoft.com/office/powerpoint/2010/main" val="784279951"/>
       </p:ext>
     </p:extLst>
   </p:cSld>
@@ -2763,7 +2763,7 @@
           <p:cNvPr id="2" name="Title Placeholder 1">
             <a:extLst>
               <a:ext uri="{FF2B5EF4-FFF2-40B4-BE49-F238E27FC236}">
-                <a16:creationId xmlns:a16="http://schemas.microsoft.com/office/drawing/2014/main" id="{52DC1AB9-C607-56B4-75CF-0659531FC8EF}"/>
+                <a16:creationId xmlns:a16="http://schemas.microsoft.com/office/drawing/2014/main" id="{DC2A4D20-F8E9-563C-DB08-82C1046C5BFA}"/>
               </a:ext>
             </a:extLst>
           </p:cNvPr>
@@ -2801,7 +2801,7 @@
           <p:cNvPr id="3" name="Text Placeholder 2">
             <a:extLst>
               <a:ext uri="{FF2B5EF4-FFF2-40B4-BE49-F238E27FC236}">
-                <a16:creationId xmlns:a16="http://schemas.microsoft.com/office/drawing/2014/main" id="{867F611B-6D07-E18C-AE83-194A0563CCD5}"/>
+                <a16:creationId xmlns:a16="http://schemas.microsoft.com/office/drawing/2014/main" id="{4480BF9F-7B44-583D-DB0B-32DBE704ED2B}"/>
               </a:ext>
             </a:extLst>
           </p:cNvPr>
@@ -2868,7 +2868,7 @@
           <p:cNvPr id="4" name="Date Placeholder 3">
             <a:extLst>
               <a:ext uri="{FF2B5EF4-FFF2-40B4-BE49-F238E27FC236}">
-                <a16:creationId xmlns:a16="http://schemas.microsoft.com/office/drawing/2014/main" id="{A58D2571-978A-1C45-6FCF-8DE1A8614867}"/>
+                <a16:creationId xmlns:a16="http://schemas.microsoft.com/office/drawing/2014/main" id="{4F4DE2CA-3044-B62E-F9F2-86957E200B14}"/>
               </a:ext>
             </a:extLst>
           </p:cNvPr>
@@ -2902,7 +2902,7 @@
             </a:lvl1pPr>
           </a:lstStyle>
           <a:p>
-            <a:fld id="{D0DC34CB-9D0C-46D2-AF83-D9E99F6E08AA}" type="datetimeFigureOut">
+            <a:fld id="{DFA09FBC-30DC-48BE-8530-D6CD85F75D45}" type="datetimeFigureOut">
               <a:rPr lang="en-US" smtClean="0"/>
               <a:t>6/25/2026</a:t>
             </a:fld>
@@ -2915,7 +2915,7 @@
           <p:cNvPr id="5" name="Footer Placeholder 4">
             <a:extLst>
               <a:ext uri="{FF2B5EF4-FFF2-40B4-BE49-F238E27FC236}">
-                <a16:creationId xmlns:a16="http://schemas.microsoft.com/office/drawing/2014/main" id="{09EDCFA3-95A7-E680-6269-D482703F130B}"/>
+                <a16:creationId xmlns:a16="http://schemas.microsoft.com/office/drawing/2014/main" id="{2F8CD0F0-F9E0-C275-82CB-8A929460C2BD}"/>
               </a:ext>
             </a:extLst>
           </p:cNvPr>
@@ -2958,7 +2958,7 @@
           <p:cNvPr id="6" name="Slide Number Placeholder 5">
             <a:extLst>
               <a:ext uri="{FF2B5EF4-FFF2-40B4-BE49-F238E27FC236}">
-                <a16:creationId xmlns:a16="http://schemas.microsoft.com/office/drawing/2014/main" id="{08204ECA-15C0-A8C5-071C-261FF337E6E5}"/>
+                <a16:creationId xmlns:a16="http://schemas.microsoft.com/office/drawing/2014/main" id="{0DDB6D36-88D8-58B4-D373-5A788855D8AB}"/>
               </a:ext>
             </a:extLst>
           </p:cNvPr>
@@ -2992,7 +2992,7 @@
             </a:lvl1pPr>
           </a:lstStyle>
           <a:p>
-            <a:fld id="{51417EEE-D195-4768-ADC3-D10258B34F23}" type="slidenum">
+            <a:fld id="{69A9D669-6F5B-41F0-8144-61566721581D}" type="slidenum">
               <a:rPr lang="en-US" smtClean="0"/>
               <a:t>‹#›</a:t>
             </a:fld>
@@ -3003,7 +3003,7 @@
     </p:spTree>
     <p:extLst>
       <p:ext uri="{BB962C8B-B14F-4D97-AF65-F5344CB8AC3E}">
-        <p14:creationId xmlns:p14="http://schemas.microsoft.com/office/powerpoint/2010/main" val="2108118689"/>
+        <p14:creationId xmlns:p14="http://schemas.microsoft.com/office/powerpoint/2010/main" val="3934274030"/>
       </p:ext>
     </p:extLst>
   </p:cSld>
@@ -3326,7 +3326,7 @@
           <p:cNvPr id="2" name="Title 1">
             <a:extLst>
               <a:ext uri="{FF2B5EF4-FFF2-40B4-BE49-F238E27FC236}">
-                <a16:creationId xmlns:a16="http://schemas.microsoft.com/office/drawing/2014/main" id="{8166A849-2DDC-E3D7-73B4-BE8944B1CCF5}"/>
+                <a16:creationId xmlns:a16="http://schemas.microsoft.com/office/drawing/2014/main" id="{3330DEC1-1998-57B6-4C9F-838CFC8DE160}"/>
               </a:ext>
             </a:extLst>
           </p:cNvPr>
@@ -3356,7 +3356,7 @@
           <p:cNvPr id="3" name="Subtitle 2">
             <a:extLst>
               <a:ext uri="{FF2B5EF4-FFF2-40B4-BE49-F238E27FC236}">
-                <a16:creationId xmlns:a16="http://schemas.microsoft.com/office/drawing/2014/main" id="{6DE81D83-7CB8-24F0-AA16-08F63761F1E9}"/>
+                <a16:creationId xmlns:a16="http://schemas.microsoft.com/office/drawing/2014/main" id="{51C0F20D-F6F2-5998-5BEC-22D6C1D21480}"/>
               </a:ext>
             </a:extLst>
           </p:cNvPr>
@@ -3384,7 +3384,7 @@
     </p:spTree>
     <p:extLst>
       <p:ext uri="{BB962C8B-B14F-4D97-AF65-F5344CB8AC3E}">
-        <p14:creationId xmlns:p14="http://schemas.microsoft.com/office/powerpoint/2010/main" val="3304708087"/>
+        <p14:creationId xmlns:p14="http://schemas.microsoft.com/office/powerpoint/2010/main" val="1484415328"/>
       </p:ext>
     </p:extLst>
   </p:cSld>

</xml_diff>

<commit_message>
feat(freep): add deck 09-smartart to corpus generator + parity = 0.67% [Wave 7C]
GenerateSmartArt generates a 5-step process diagram deck via PowerPoint COM
(AddSmartArt where available, solid-fill rectangles as fallback). Parity
measurement: slide-01 mean diff 0.6665% vs PowerPoint export — well within
acceptable range. 9/9 corpus decks generated successfully.

Co-Authored-By: Claude Opus 4.8 <noreply@anthropic.com>
</commit_message>
<xml_diff>
--- a/tools/FreeP.RenderCompare/corpus/01-title-slide.pptx
+++ b/tools/FreeP.RenderCompare/corpus/01-title-slide.pptx
@@ -129,7 +129,7 @@
           <p:cNvPr id="2" name="Title 1">
             <a:extLst>
               <a:ext uri="{FF2B5EF4-FFF2-40B4-BE49-F238E27FC236}">
-                <a16:creationId xmlns:a16="http://schemas.microsoft.com/office/drawing/2014/main" id="{46A67694-1CC0-C003-1E4E-ED236B2269DF}"/>
+                <a16:creationId xmlns:a16="http://schemas.microsoft.com/office/drawing/2014/main" id="{75E33B52-1F93-3E3B-73B0-BA7D2C9A202A}"/>
               </a:ext>
             </a:extLst>
           </p:cNvPr>
@@ -166,7 +166,7 @@
           <p:cNvPr id="3" name="Subtitle 2">
             <a:extLst>
               <a:ext uri="{FF2B5EF4-FFF2-40B4-BE49-F238E27FC236}">
-                <a16:creationId xmlns:a16="http://schemas.microsoft.com/office/drawing/2014/main" id="{BD71AB08-3AF3-DB6F-3AB2-D4F433E0ED89}"/>
+                <a16:creationId xmlns:a16="http://schemas.microsoft.com/office/drawing/2014/main" id="{C845CC97-914E-84C6-9E02-08D336E72A53}"/>
               </a:ext>
             </a:extLst>
           </p:cNvPr>
@@ -236,7 +236,7 @@
           <p:cNvPr id="4" name="Date Placeholder 3">
             <a:extLst>
               <a:ext uri="{FF2B5EF4-FFF2-40B4-BE49-F238E27FC236}">
-                <a16:creationId xmlns:a16="http://schemas.microsoft.com/office/drawing/2014/main" id="{391BAFDF-B2E3-3CF0-9073-83E8F3C75CE4}"/>
+                <a16:creationId xmlns:a16="http://schemas.microsoft.com/office/drawing/2014/main" id="{4E6EBDB3-2FF4-9157-AA40-85617883DE2F}"/>
               </a:ext>
             </a:extLst>
           </p:cNvPr>
@@ -252,9 +252,9 @@
           <a:bodyPr/>
           <a:lstStyle/>
           <a:p>
-            <a:fld id="{DFA09FBC-30DC-48BE-8530-D6CD85F75D45}" type="datetimeFigureOut">
+            <a:fld id="{1F8D42F4-7471-47FA-A915-491041C92066}" type="datetimeFigureOut">
               <a:rPr lang="en-US" smtClean="0"/>
-              <a:t>6/25/2026</a:t>
+              <a:t>6/26/2026</a:t>
             </a:fld>
             <a:endParaRPr lang="en-US"/>
           </a:p>
@@ -265,7 +265,7 @@
           <p:cNvPr id="5" name="Footer Placeholder 4">
             <a:extLst>
               <a:ext uri="{FF2B5EF4-FFF2-40B4-BE49-F238E27FC236}">
-                <a16:creationId xmlns:a16="http://schemas.microsoft.com/office/drawing/2014/main" id="{9C7DF908-A66F-A521-848E-277A3095B2ED}"/>
+                <a16:creationId xmlns:a16="http://schemas.microsoft.com/office/drawing/2014/main" id="{E0C2FAA1-E138-3566-5708-18F7543F8DAA}"/>
               </a:ext>
             </a:extLst>
           </p:cNvPr>
@@ -290,7 +290,7 @@
           <p:cNvPr id="6" name="Slide Number Placeholder 5">
             <a:extLst>
               <a:ext uri="{FF2B5EF4-FFF2-40B4-BE49-F238E27FC236}">
-                <a16:creationId xmlns:a16="http://schemas.microsoft.com/office/drawing/2014/main" id="{1781CAF9-3D40-1EBA-7757-EF932A1E2678}"/>
+                <a16:creationId xmlns:a16="http://schemas.microsoft.com/office/drawing/2014/main" id="{C044084D-B885-5468-1AC2-C04CE23256EE}"/>
               </a:ext>
             </a:extLst>
           </p:cNvPr>
@@ -306,7 +306,7 @@
           <a:bodyPr/>
           <a:lstStyle/>
           <a:p>
-            <a:fld id="{69A9D669-6F5B-41F0-8144-61566721581D}" type="slidenum">
+            <a:fld id="{BCEB5019-9AEC-4FB4-9C3E-3AEB2984872B}" type="slidenum">
               <a:rPr lang="en-US" smtClean="0"/>
               <a:t>‹#›</a:t>
             </a:fld>
@@ -317,7 +317,7 @@
     </p:spTree>
     <p:extLst>
       <p:ext uri="{BB962C8B-B14F-4D97-AF65-F5344CB8AC3E}">
-        <p14:creationId xmlns:p14="http://schemas.microsoft.com/office/powerpoint/2010/main" val="2786701469"/>
+        <p14:creationId xmlns:p14="http://schemas.microsoft.com/office/powerpoint/2010/main" val="2792050403"/>
       </p:ext>
     </p:extLst>
   </p:cSld>
@@ -349,7 +349,7 @@
           <p:cNvPr id="2" name="Title 1">
             <a:extLst>
               <a:ext uri="{FF2B5EF4-FFF2-40B4-BE49-F238E27FC236}">
-                <a16:creationId xmlns:a16="http://schemas.microsoft.com/office/drawing/2014/main" id="{2B559070-E62F-13A5-CB52-48A0E4F06FDE}"/>
+                <a16:creationId xmlns:a16="http://schemas.microsoft.com/office/drawing/2014/main" id="{05D2E4E2-48B1-CE92-4D29-5E9D19C3A183}"/>
               </a:ext>
             </a:extLst>
           </p:cNvPr>
@@ -377,7 +377,7 @@
           <p:cNvPr id="3" name="Vertical Text Placeholder 2">
             <a:extLst>
               <a:ext uri="{FF2B5EF4-FFF2-40B4-BE49-F238E27FC236}">
-                <a16:creationId xmlns:a16="http://schemas.microsoft.com/office/drawing/2014/main" id="{AE420098-9A49-ED49-1D4A-AE25B8B63C9D}"/>
+                <a16:creationId xmlns:a16="http://schemas.microsoft.com/office/drawing/2014/main" id="{B5CA89E0-BFFF-E002-9E6E-1C499B3AD574}"/>
               </a:ext>
             </a:extLst>
           </p:cNvPr>
@@ -434,7 +434,7 @@
           <p:cNvPr id="4" name="Date Placeholder 3">
             <a:extLst>
               <a:ext uri="{FF2B5EF4-FFF2-40B4-BE49-F238E27FC236}">
-                <a16:creationId xmlns:a16="http://schemas.microsoft.com/office/drawing/2014/main" id="{0D5ACE03-2470-075A-D716-B1B9D2CF6CE9}"/>
+                <a16:creationId xmlns:a16="http://schemas.microsoft.com/office/drawing/2014/main" id="{23D99659-BEEA-F576-044B-F6B66BE134B4}"/>
               </a:ext>
             </a:extLst>
           </p:cNvPr>
@@ -450,9 +450,9 @@
           <a:bodyPr/>
           <a:lstStyle/>
           <a:p>
-            <a:fld id="{DFA09FBC-30DC-48BE-8530-D6CD85F75D45}" type="datetimeFigureOut">
+            <a:fld id="{1F8D42F4-7471-47FA-A915-491041C92066}" type="datetimeFigureOut">
               <a:rPr lang="en-US" smtClean="0"/>
-              <a:t>6/25/2026</a:t>
+              <a:t>6/26/2026</a:t>
             </a:fld>
             <a:endParaRPr lang="en-US"/>
           </a:p>
@@ -463,7 +463,7 @@
           <p:cNvPr id="5" name="Footer Placeholder 4">
             <a:extLst>
               <a:ext uri="{FF2B5EF4-FFF2-40B4-BE49-F238E27FC236}">
-                <a16:creationId xmlns:a16="http://schemas.microsoft.com/office/drawing/2014/main" id="{CFECD791-B351-8C20-045A-C5BDE9844C18}"/>
+                <a16:creationId xmlns:a16="http://schemas.microsoft.com/office/drawing/2014/main" id="{A95CF602-6C37-2EC2-AEF6-64768ADFE0AD}"/>
               </a:ext>
             </a:extLst>
           </p:cNvPr>
@@ -488,7 +488,7 @@
           <p:cNvPr id="6" name="Slide Number Placeholder 5">
             <a:extLst>
               <a:ext uri="{FF2B5EF4-FFF2-40B4-BE49-F238E27FC236}">
-                <a16:creationId xmlns:a16="http://schemas.microsoft.com/office/drawing/2014/main" id="{6507EEF0-F54E-1794-48FF-62CDC86BCE33}"/>
+                <a16:creationId xmlns:a16="http://schemas.microsoft.com/office/drawing/2014/main" id="{1F34A20C-6B61-580A-283B-8E67B427355C}"/>
               </a:ext>
             </a:extLst>
           </p:cNvPr>
@@ -504,7 +504,7 @@
           <a:bodyPr/>
           <a:lstStyle/>
           <a:p>
-            <a:fld id="{69A9D669-6F5B-41F0-8144-61566721581D}" type="slidenum">
+            <a:fld id="{BCEB5019-9AEC-4FB4-9C3E-3AEB2984872B}" type="slidenum">
               <a:rPr lang="en-US" smtClean="0"/>
               <a:t>‹#›</a:t>
             </a:fld>
@@ -515,7 +515,7 @@
     </p:spTree>
     <p:extLst>
       <p:ext uri="{BB962C8B-B14F-4D97-AF65-F5344CB8AC3E}">
-        <p14:creationId xmlns:p14="http://schemas.microsoft.com/office/powerpoint/2010/main" val="176025288"/>
+        <p14:creationId xmlns:p14="http://schemas.microsoft.com/office/powerpoint/2010/main" val="1729200183"/>
       </p:ext>
     </p:extLst>
   </p:cSld>
@@ -547,7 +547,7 @@
           <p:cNvPr id="2" name="Vertical Title 1">
             <a:extLst>
               <a:ext uri="{FF2B5EF4-FFF2-40B4-BE49-F238E27FC236}">
-                <a16:creationId xmlns:a16="http://schemas.microsoft.com/office/drawing/2014/main" id="{DB03D7E4-D985-4663-BB9C-48DBAEBA0910}"/>
+                <a16:creationId xmlns:a16="http://schemas.microsoft.com/office/drawing/2014/main" id="{E31B4CB9-E31A-E712-C63D-3C6E8643A6E6}"/>
               </a:ext>
             </a:extLst>
           </p:cNvPr>
@@ -580,7 +580,7 @@
           <p:cNvPr id="3" name="Vertical Text Placeholder 2">
             <a:extLst>
               <a:ext uri="{FF2B5EF4-FFF2-40B4-BE49-F238E27FC236}">
-                <a16:creationId xmlns:a16="http://schemas.microsoft.com/office/drawing/2014/main" id="{4FF3F1D6-9C33-5752-DD11-F149E786320D}"/>
+                <a16:creationId xmlns:a16="http://schemas.microsoft.com/office/drawing/2014/main" id="{F61E7196-3CD8-74C9-CC08-A75C87BDCB96}"/>
               </a:ext>
             </a:extLst>
           </p:cNvPr>
@@ -642,7 +642,7 @@
           <p:cNvPr id="4" name="Date Placeholder 3">
             <a:extLst>
               <a:ext uri="{FF2B5EF4-FFF2-40B4-BE49-F238E27FC236}">
-                <a16:creationId xmlns:a16="http://schemas.microsoft.com/office/drawing/2014/main" id="{58A7B7FB-BEEC-4FA2-EE47-7EF94864D270}"/>
+                <a16:creationId xmlns:a16="http://schemas.microsoft.com/office/drawing/2014/main" id="{9F8546BE-AEA8-CB60-CA89-4350CAD04339}"/>
               </a:ext>
             </a:extLst>
           </p:cNvPr>
@@ -658,9 +658,9 @@
           <a:bodyPr/>
           <a:lstStyle/>
           <a:p>
-            <a:fld id="{DFA09FBC-30DC-48BE-8530-D6CD85F75D45}" type="datetimeFigureOut">
+            <a:fld id="{1F8D42F4-7471-47FA-A915-491041C92066}" type="datetimeFigureOut">
               <a:rPr lang="en-US" smtClean="0"/>
-              <a:t>6/25/2026</a:t>
+              <a:t>6/26/2026</a:t>
             </a:fld>
             <a:endParaRPr lang="en-US"/>
           </a:p>
@@ -671,7 +671,7 @@
           <p:cNvPr id="5" name="Footer Placeholder 4">
             <a:extLst>
               <a:ext uri="{FF2B5EF4-FFF2-40B4-BE49-F238E27FC236}">
-                <a16:creationId xmlns:a16="http://schemas.microsoft.com/office/drawing/2014/main" id="{6B078AD5-945C-4C95-9853-9160C73A2418}"/>
+                <a16:creationId xmlns:a16="http://schemas.microsoft.com/office/drawing/2014/main" id="{5E823CB0-396B-23D8-0D8B-C5D11E0E37EB}"/>
               </a:ext>
             </a:extLst>
           </p:cNvPr>
@@ -696,7 +696,7 @@
           <p:cNvPr id="6" name="Slide Number Placeholder 5">
             <a:extLst>
               <a:ext uri="{FF2B5EF4-FFF2-40B4-BE49-F238E27FC236}">
-                <a16:creationId xmlns:a16="http://schemas.microsoft.com/office/drawing/2014/main" id="{34E761FC-2E80-0140-25D3-7B7BC5A07472}"/>
+                <a16:creationId xmlns:a16="http://schemas.microsoft.com/office/drawing/2014/main" id="{83178120-D576-D10E-1340-739565FC4B1B}"/>
               </a:ext>
             </a:extLst>
           </p:cNvPr>
@@ -712,7 +712,7 @@
           <a:bodyPr/>
           <a:lstStyle/>
           <a:p>
-            <a:fld id="{69A9D669-6F5B-41F0-8144-61566721581D}" type="slidenum">
+            <a:fld id="{BCEB5019-9AEC-4FB4-9C3E-3AEB2984872B}" type="slidenum">
               <a:rPr lang="en-US" smtClean="0"/>
               <a:t>‹#›</a:t>
             </a:fld>
@@ -723,7 +723,7 @@
     </p:spTree>
     <p:extLst>
       <p:ext uri="{BB962C8B-B14F-4D97-AF65-F5344CB8AC3E}">
-        <p14:creationId xmlns:p14="http://schemas.microsoft.com/office/powerpoint/2010/main" val="2907214330"/>
+        <p14:creationId xmlns:p14="http://schemas.microsoft.com/office/powerpoint/2010/main" val="1262502568"/>
       </p:ext>
     </p:extLst>
   </p:cSld>
@@ -755,7 +755,7 @@
           <p:cNvPr id="2" name="Title 1">
             <a:extLst>
               <a:ext uri="{FF2B5EF4-FFF2-40B4-BE49-F238E27FC236}">
-                <a16:creationId xmlns:a16="http://schemas.microsoft.com/office/drawing/2014/main" id="{B2858912-8F08-3E17-A93E-28B05AA4AE3B}"/>
+                <a16:creationId xmlns:a16="http://schemas.microsoft.com/office/drawing/2014/main" id="{534B5C06-EAF3-46AE-D9B5-849F5CA0D5DE}"/>
               </a:ext>
             </a:extLst>
           </p:cNvPr>
@@ -783,7 +783,7 @@
           <p:cNvPr id="3" name="Content Placeholder 2">
             <a:extLst>
               <a:ext uri="{FF2B5EF4-FFF2-40B4-BE49-F238E27FC236}">
-                <a16:creationId xmlns:a16="http://schemas.microsoft.com/office/drawing/2014/main" id="{5C32C149-FA94-1191-3E0E-55FEC83AC4DC}"/>
+                <a16:creationId xmlns:a16="http://schemas.microsoft.com/office/drawing/2014/main" id="{30457BE7-454D-D601-6F70-D4D926D16817}"/>
               </a:ext>
             </a:extLst>
           </p:cNvPr>
@@ -840,7 +840,7 @@
           <p:cNvPr id="4" name="Date Placeholder 3">
             <a:extLst>
               <a:ext uri="{FF2B5EF4-FFF2-40B4-BE49-F238E27FC236}">
-                <a16:creationId xmlns:a16="http://schemas.microsoft.com/office/drawing/2014/main" id="{E77F6980-1779-C3FE-072C-1C46C6A417BF}"/>
+                <a16:creationId xmlns:a16="http://schemas.microsoft.com/office/drawing/2014/main" id="{D8F71B22-1BE0-8571-4CF3-5C4D308EC255}"/>
               </a:ext>
             </a:extLst>
           </p:cNvPr>
@@ -856,9 +856,9 @@
           <a:bodyPr/>
           <a:lstStyle/>
           <a:p>
-            <a:fld id="{DFA09FBC-30DC-48BE-8530-D6CD85F75D45}" type="datetimeFigureOut">
+            <a:fld id="{1F8D42F4-7471-47FA-A915-491041C92066}" type="datetimeFigureOut">
               <a:rPr lang="en-US" smtClean="0"/>
-              <a:t>6/25/2026</a:t>
+              <a:t>6/26/2026</a:t>
             </a:fld>
             <a:endParaRPr lang="en-US"/>
           </a:p>
@@ -869,7 +869,7 @@
           <p:cNvPr id="5" name="Footer Placeholder 4">
             <a:extLst>
               <a:ext uri="{FF2B5EF4-FFF2-40B4-BE49-F238E27FC236}">
-                <a16:creationId xmlns:a16="http://schemas.microsoft.com/office/drawing/2014/main" id="{D52FD724-F416-4D53-1C15-F86C2F23F678}"/>
+                <a16:creationId xmlns:a16="http://schemas.microsoft.com/office/drawing/2014/main" id="{A58B8A27-BCC0-CE5B-820B-B143763DAF40}"/>
               </a:ext>
             </a:extLst>
           </p:cNvPr>
@@ -894,7 +894,7 @@
           <p:cNvPr id="6" name="Slide Number Placeholder 5">
             <a:extLst>
               <a:ext uri="{FF2B5EF4-FFF2-40B4-BE49-F238E27FC236}">
-                <a16:creationId xmlns:a16="http://schemas.microsoft.com/office/drawing/2014/main" id="{C606177F-BBAE-6EB6-7D2A-CF15B4B4889B}"/>
+                <a16:creationId xmlns:a16="http://schemas.microsoft.com/office/drawing/2014/main" id="{03E01FF1-7B19-9CF4-A95B-2E2B6D86C638}"/>
               </a:ext>
             </a:extLst>
           </p:cNvPr>
@@ -910,7 +910,7 @@
           <a:bodyPr/>
           <a:lstStyle/>
           <a:p>
-            <a:fld id="{69A9D669-6F5B-41F0-8144-61566721581D}" type="slidenum">
+            <a:fld id="{BCEB5019-9AEC-4FB4-9C3E-3AEB2984872B}" type="slidenum">
               <a:rPr lang="en-US" smtClean="0"/>
               <a:t>‹#›</a:t>
             </a:fld>
@@ -921,7 +921,7 @@
     </p:spTree>
     <p:extLst>
       <p:ext uri="{BB962C8B-B14F-4D97-AF65-F5344CB8AC3E}">
-        <p14:creationId xmlns:p14="http://schemas.microsoft.com/office/powerpoint/2010/main" val="3380224604"/>
+        <p14:creationId xmlns:p14="http://schemas.microsoft.com/office/powerpoint/2010/main" val="3642929470"/>
       </p:ext>
     </p:extLst>
   </p:cSld>
@@ -953,7 +953,7 @@
           <p:cNvPr id="2" name="Title 1">
             <a:extLst>
               <a:ext uri="{FF2B5EF4-FFF2-40B4-BE49-F238E27FC236}">
-                <a16:creationId xmlns:a16="http://schemas.microsoft.com/office/drawing/2014/main" id="{2342C4B2-0E9D-C37E-9613-4410E7E89ADD}"/>
+                <a16:creationId xmlns:a16="http://schemas.microsoft.com/office/drawing/2014/main" id="{10C6C117-978B-BF6F-87C4-C1A77C825B46}"/>
               </a:ext>
             </a:extLst>
           </p:cNvPr>
@@ -990,7 +990,7 @@
           <p:cNvPr id="3" name="Text Placeholder 2">
             <a:extLst>
               <a:ext uri="{FF2B5EF4-FFF2-40B4-BE49-F238E27FC236}">
-                <a16:creationId xmlns:a16="http://schemas.microsoft.com/office/drawing/2014/main" id="{45150BE7-A2CB-B91A-19CA-DF6544492112}"/>
+                <a16:creationId xmlns:a16="http://schemas.microsoft.com/office/drawing/2014/main" id="{498D213B-105C-17A9-D8FF-73587B966686}"/>
               </a:ext>
             </a:extLst>
           </p:cNvPr>
@@ -1115,7 +1115,7 @@
           <p:cNvPr id="4" name="Date Placeholder 3">
             <a:extLst>
               <a:ext uri="{FF2B5EF4-FFF2-40B4-BE49-F238E27FC236}">
-                <a16:creationId xmlns:a16="http://schemas.microsoft.com/office/drawing/2014/main" id="{13045FB9-E9C4-7FE3-0326-B2ADB4F4B327}"/>
+                <a16:creationId xmlns:a16="http://schemas.microsoft.com/office/drawing/2014/main" id="{6B6F17F0-4E1B-AC8F-792A-F9459AC7AF0C}"/>
               </a:ext>
             </a:extLst>
           </p:cNvPr>
@@ -1131,9 +1131,9 @@
           <a:bodyPr/>
           <a:lstStyle/>
           <a:p>
-            <a:fld id="{DFA09FBC-30DC-48BE-8530-D6CD85F75D45}" type="datetimeFigureOut">
+            <a:fld id="{1F8D42F4-7471-47FA-A915-491041C92066}" type="datetimeFigureOut">
               <a:rPr lang="en-US" smtClean="0"/>
-              <a:t>6/25/2026</a:t>
+              <a:t>6/26/2026</a:t>
             </a:fld>
             <a:endParaRPr lang="en-US"/>
           </a:p>
@@ -1144,7 +1144,7 @@
           <p:cNvPr id="5" name="Footer Placeholder 4">
             <a:extLst>
               <a:ext uri="{FF2B5EF4-FFF2-40B4-BE49-F238E27FC236}">
-                <a16:creationId xmlns:a16="http://schemas.microsoft.com/office/drawing/2014/main" id="{7E19391B-5745-827B-C43E-318A47F45819}"/>
+                <a16:creationId xmlns:a16="http://schemas.microsoft.com/office/drawing/2014/main" id="{C792DA2A-9EF1-63C8-F4BF-AC64BB9A698F}"/>
               </a:ext>
             </a:extLst>
           </p:cNvPr>
@@ -1169,7 +1169,7 @@
           <p:cNvPr id="6" name="Slide Number Placeholder 5">
             <a:extLst>
               <a:ext uri="{FF2B5EF4-FFF2-40B4-BE49-F238E27FC236}">
-                <a16:creationId xmlns:a16="http://schemas.microsoft.com/office/drawing/2014/main" id="{C2DEA631-998D-A42C-278E-77FCED0CFE62}"/>
+                <a16:creationId xmlns:a16="http://schemas.microsoft.com/office/drawing/2014/main" id="{DBE08F98-4CED-7917-5B26-A9AF53DEE162}"/>
               </a:ext>
             </a:extLst>
           </p:cNvPr>
@@ -1185,7 +1185,7 @@
           <a:bodyPr/>
           <a:lstStyle/>
           <a:p>
-            <a:fld id="{69A9D669-6F5B-41F0-8144-61566721581D}" type="slidenum">
+            <a:fld id="{BCEB5019-9AEC-4FB4-9C3E-3AEB2984872B}" type="slidenum">
               <a:rPr lang="en-US" smtClean="0"/>
               <a:t>‹#›</a:t>
             </a:fld>
@@ -1196,7 +1196,7 @@
     </p:spTree>
     <p:extLst>
       <p:ext uri="{BB962C8B-B14F-4D97-AF65-F5344CB8AC3E}">
-        <p14:creationId xmlns:p14="http://schemas.microsoft.com/office/powerpoint/2010/main" val="772151082"/>
+        <p14:creationId xmlns:p14="http://schemas.microsoft.com/office/powerpoint/2010/main" val="3664786976"/>
       </p:ext>
     </p:extLst>
   </p:cSld>
@@ -1228,7 +1228,7 @@
           <p:cNvPr id="2" name="Title 1">
             <a:extLst>
               <a:ext uri="{FF2B5EF4-FFF2-40B4-BE49-F238E27FC236}">
-                <a16:creationId xmlns:a16="http://schemas.microsoft.com/office/drawing/2014/main" id="{BC12A5E4-6040-F308-E144-AAC371C71900}"/>
+                <a16:creationId xmlns:a16="http://schemas.microsoft.com/office/drawing/2014/main" id="{807475D6-DB58-EF84-BDEE-18331A12E851}"/>
               </a:ext>
             </a:extLst>
           </p:cNvPr>
@@ -1256,7 +1256,7 @@
           <p:cNvPr id="3" name="Content Placeholder 2">
             <a:extLst>
               <a:ext uri="{FF2B5EF4-FFF2-40B4-BE49-F238E27FC236}">
-                <a16:creationId xmlns:a16="http://schemas.microsoft.com/office/drawing/2014/main" id="{F92F4DC4-AF56-D51D-9E3C-51A430D27C81}"/>
+                <a16:creationId xmlns:a16="http://schemas.microsoft.com/office/drawing/2014/main" id="{8176807F-3505-8ED9-D77D-EDEC04DF0104}"/>
               </a:ext>
             </a:extLst>
           </p:cNvPr>
@@ -1318,7 +1318,7 @@
           <p:cNvPr id="4" name="Content Placeholder 3">
             <a:extLst>
               <a:ext uri="{FF2B5EF4-FFF2-40B4-BE49-F238E27FC236}">
-                <a16:creationId xmlns:a16="http://schemas.microsoft.com/office/drawing/2014/main" id="{7A8641FC-F55C-A6F8-2361-3F9BB3DB350E}"/>
+                <a16:creationId xmlns:a16="http://schemas.microsoft.com/office/drawing/2014/main" id="{F8B0D688-CE80-F68A-A3F6-E729ABA09082}"/>
               </a:ext>
             </a:extLst>
           </p:cNvPr>
@@ -1380,7 +1380,7 @@
           <p:cNvPr id="5" name="Date Placeholder 4">
             <a:extLst>
               <a:ext uri="{FF2B5EF4-FFF2-40B4-BE49-F238E27FC236}">
-                <a16:creationId xmlns:a16="http://schemas.microsoft.com/office/drawing/2014/main" id="{A36F0BC3-627F-6D17-E3E6-A4BFF4A6FF05}"/>
+                <a16:creationId xmlns:a16="http://schemas.microsoft.com/office/drawing/2014/main" id="{D2E4965E-6E68-B68E-E906-00C97F0B861B}"/>
               </a:ext>
             </a:extLst>
           </p:cNvPr>
@@ -1396,9 +1396,9 @@
           <a:bodyPr/>
           <a:lstStyle/>
           <a:p>
-            <a:fld id="{DFA09FBC-30DC-48BE-8530-D6CD85F75D45}" type="datetimeFigureOut">
+            <a:fld id="{1F8D42F4-7471-47FA-A915-491041C92066}" type="datetimeFigureOut">
               <a:rPr lang="en-US" smtClean="0"/>
-              <a:t>6/25/2026</a:t>
+              <a:t>6/26/2026</a:t>
             </a:fld>
             <a:endParaRPr lang="en-US"/>
           </a:p>
@@ -1409,7 +1409,7 @@
           <p:cNvPr id="6" name="Footer Placeholder 5">
             <a:extLst>
               <a:ext uri="{FF2B5EF4-FFF2-40B4-BE49-F238E27FC236}">
-                <a16:creationId xmlns:a16="http://schemas.microsoft.com/office/drawing/2014/main" id="{CD58825E-F9B3-A42A-2DA9-FFC8B617BA62}"/>
+                <a16:creationId xmlns:a16="http://schemas.microsoft.com/office/drawing/2014/main" id="{01CB5D53-9FDE-CB71-F70D-77028F1F2FA4}"/>
               </a:ext>
             </a:extLst>
           </p:cNvPr>
@@ -1434,7 +1434,7 @@
           <p:cNvPr id="7" name="Slide Number Placeholder 6">
             <a:extLst>
               <a:ext uri="{FF2B5EF4-FFF2-40B4-BE49-F238E27FC236}">
-                <a16:creationId xmlns:a16="http://schemas.microsoft.com/office/drawing/2014/main" id="{E231A3DF-2B66-3BCA-29ED-9DEBDEA2AFA3}"/>
+                <a16:creationId xmlns:a16="http://schemas.microsoft.com/office/drawing/2014/main" id="{1B8217D4-3460-2456-847A-A4FD9ED7CFE5}"/>
               </a:ext>
             </a:extLst>
           </p:cNvPr>
@@ -1450,7 +1450,7 @@
           <a:bodyPr/>
           <a:lstStyle/>
           <a:p>
-            <a:fld id="{69A9D669-6F5B-41F0-8144-61566721581D}" type="slidenum">
+            <a:fld id="{BCEB5019-9AEC-4FB4-9C3E-3AEB2984872B}" type="slidenum">
               <a:rPr lang="en-US" smtClean="0"/>
               <a:t>‹#›</a:t>
             </a:fld>
@@ -1461,7 +1461,7 @@
     </p:spTree>
     <p:extLst>
       <p:ext uri="{BB962C8B-B14F-4D97-AF65-F5344CB8AC3E}">
-        <p14:creationId xmlns:p14="http://schemas.microsoft.com/office/powerpoint/2010/main" val="2583676062"/>
+        <p14:creationId xmlns:p14="http://schemas.microsoft.com/office/powerpoint/2010/main" val="2654450808"/>
       </p:ext>
     </p:extLst>
   </p:cSld>
@@ -1493,7 +1493,7 @@
           <p:cNvPr id="2" name="Title 1">
             <a:extLst>
               <a:ext uri="{FF2B5EF4-FFF2-40B4-BE49-F238E27FC236}">
-                <a16:creationId xmlns:a16="http://schemas.microsoft.com/office/drawing/2014/main" id="{7F34F8B4-1D32-AC6E-3397-D286F2F0E827}"/>
+                <a16:creationId xmlns:a16="http://schemas.microsoft.com/office/drawing/2014/main" id="{31F95BAA-7749-5E24-CD0A-1E02833CC9AF}"/>
               </a:ext>
             </a:extLst>
           </p:cNvPr>
@@ -1526,7 +1526,7 @@
           <p:cNvPr id="3" name="Text Placeholder 2">
             <a:extLst>
               <a:ext uri="{FF2B5EF4-FFF2-40B4-BE49-F238E27FC236}">
-                <a16:creationId xmlns:a16="http://schemas.microsoft.com/office/drawing/2014/main" id="{527D9DA0-6DEA-5D17-11C9-EA313D745A05}"/>
+                <a16:creationId xmlns:a16="http://schemas.microsoft.com/office/drawing/2014/main" id="{B1A04120-ADC6-A7BC-619E-99A8FE3C41BD}"/>
               </a:ext>
             </a:extLst>
           </p:cNvPr>
@@ -1597,7 +1597,7 @@
           <p:cNvPr id="4" name="Content Placeholder 3">
             <a:extLst>
               <a:ext uri="{FF2B5EF4-FFF2-40B4-BE49-F238E27FC236}">
-                <a16:creationId xmlns:a16="http://schemas.microsoft.com/office/drawing/2014/main" id="{CD995310-AB54-078E-F812-F0EC2BD188C8}"/>
+                <a16:creationId xmlns:a16="http://schemas.microsoft.com/office/drawing/2014/main" id="{06B0509E-3178-11C8-7520-1B274CAA04F0}"/>
               </a:ext>
             </a:extLst>
           </p:cNvPr>
@@ -1659,7 +1659,7 @@
           <p:cNvPr id="5" name="Text Placeholder 4">
             <a:extLst>
               <a:ext uri="{FF2B5EF4-FFF2-40B4-BE49-F238E27FC236}">
-                <a16:creationId xmlns:a16="http://schemas.microsoft.com/office/drawing/2014/main" id="{A6F7410B-9D66-4C95-1308-C42716ADADA8}"/>
+                <a16:creationId xmlns:a16="http://schemas.microsoft.com/office/drawing/2014/main" id="{3592EDD3-C145-8899-776A-46658B2F67C4}"/>
               </a:ext>
             </a:extLst>
           </p:cNvPr>
@@ -1730,7 +1730,7 @@
           <p:cNvPr id="6" name="Content Placeholder 5">
             <a:extLst>
               <a:ext uri="{FF2B5EF4-FFF2-40B4-BE49-F238E27FC236}">
-                <a16:creationId xmlns:a16="http://schemas.microsoft.com/office/drawing/2014/main" id="{A237C342-FEA2-D1EB-F4F1-560E837DAF04}"/>
+                <a16:creationId xmlns:a16="http://schemas.microsoft.com/office/drawing/2014/main" id="{EFB9932E-C14E-CCEC-FF7A-895F579F7301}"/>
               </a:ext>
             </a:extLst>
           </p:cNvPr>
@@ -1792,7 +1792,7 @@
           <p:cNvPr id="7" name="Date Placeholder 6">
             <a:extLst>
               <a:ext uri="{FF2B5EF4-FFF2-40B4-BE49-F238E27FC236}">
-                <a16:creationId xmlns:a16="http://schemas.microsoft.com/office/drawing/2014/main" id="{F690B6A9-002C-58CF-31CB-55E128FB5698}"/>
+                <a16:creationId xmlns:a16="http://schemas.microsoft.com/office/drawing/2014/main" id="{AE1E6229-D75B-5B7A-6A8A-D0C9F92723C5}"/>
               </a:ext>
             </a:extLst>
           </p:cNvPr>
@@ -1808,9 +1808,9 @@
           <a:bodyPr/>
           <a:lstStyle/>
           <a:p>
-            <a:fld id="{DFA09FBC-30DC-48BE-8530-D6CD85F75D45}" type="datetimeFigureOut">
+            <a:fld id="{1F8D42F4-7471-47FA-A915-491041C92066}" type="datetimeFigureOut">
               <a:rPr lang="en-US" smtClean="0"/>
-              <a:t>6/25/2026</a:t>
+              <a:t>6/26/2026</a:t>
             </a:fld>
             <a:endParaRPr lang="en-US"/>
           </a:p>
@@ -1821,7 +1821,7 @@
           <p:cNvPr id="8" name="Footer Placeholder 7">
             <a:extLst>
               <a:ext uri="{FF2B5EF4-FFF2-40B4-BE49-F238E27FC236}">
-                <a16:creationId xmlns:a16="http://schemas.microsoft.com/office/drawing/2014/main" id="{8EDBCD60-1D39-25E2-4AA5-DABF0181D73F}"/>
+                <a16:creationId xmlns:a16="http://schemas.microsoft.com/office/drawing/2014/main" id="{A0555595-4D56-C8AC-932E-A07C004B696E}"/>
               </a:ext>
             </a:extLst>
           </p:cNvPr>
@@ -1846,7 +1846,7 @@
           <p:cNvPr id="9" name="Slide Number Placeholder 8">
             <a:extLst>
               <a:ext uri="{FF2B5EF4-FFF2-40B4-BE49-F238E27FC236}">
-                <a16:creationId xmlns:a16="http://schemas.microsoft.com/office/drawing/2014/main" id="{C46E4CDA-87CB-2241-156D-837DDEC3B4EC}"/>
+                <a16:creationId xmlns:a16="http://schemas.microsoft.com/office/drawing/2014/main" id="{00E350C1-029E-04CA-6AC6-C7612CB8A011}"/>
               </a:ext>
             </a:extLst>
           </p:cNvPr>
@@ -1862,7 +1862,7 @@
           <a:bodyPr/>
           <a:lstStyle/>
           <a:p>
-            <a:fld id="{69A9D669-6F5B-41F0-8144-61566721581D}" type="slidenum">
+            <a:fld id="{BCEB5019-9AEC-4FB4-9C3E-3AEB2984872B}" type="slidenum">
               <a:rPr lang="en-US" smtClean="0"/>
               <a:t>‹#›</a:t>
             </a:fld>
@@ -1873,7 +1873,7 @@
     </p:spTree>
     <p:extLst>
       <p:ext uri="{BB962C8B-B14F-4D97-AF65-F5344CB8AC3E}">
-        <p14:creationId xmlns:p14="http://schemas.microsoft.com/office/powerpoint/2010/main" val="2839370475"/>
+        <p14:creationId xmlns:p14="http://schemas.microsoft.com/office/powerpoint/2010/main" val="3802187567"/>
       </p:ext>
     </p:extLst>
   </p:cSld>
@@ -1905,7 +1905,7 @@
           <p:cNvPr id="2" name="Title 1">
             <a:extLst>
               <a:ext uri="{FF2B5EF4-FFF2-40B4-BE49-F238E27FC236}">
-                <a16:creationId xmlns:a16="http://schemas.microsoft.com/office/drawing/2014/main" id="{B3C70B61-CB3C-6244-0AC1-D3C487FF7103}"/>
+                <a16:creationId xmlns:a16="http://schemas.microsoft.com/office/drawing/2014/main" id="{247956DB-45FD-2AAB-2FCF-5373E5B66A3C}"/>
               </a:ext>
             </a:extLst>
           </p:cNvPr>
@@ -1933,7 +1933,7 @@
           <p:cNvPr id="3" name="Date Placeholder 2">
             <a:extLst>
               <a:ext uri="{FF2B5EF4-FFF2-40B4-BE49-F238E27FC236}">
-                <a16:creationId xmlns:a16="http://schemas.microsoft.com/office/drawing/2014/main" id="{D1277E42-D392-302A-79B5-7356811E106F}"/>
+                <a16:creationId xmlns:a16="http://schemas.microsoft.com/office/drawing/2014/main" id="{EA2D24CD-B0A9-298B-BCF9-C412EBB16CA9}"/>
               </a:ext>
             </a:extLst>
           </p:cNvPr>
@@ -1949,9 +1949,9 @@
           <a:bodyPr/>
           <a:lstStyle/>
           <a:p>
-            <a:fld id="{DFA09FBC-30DC-48BE-8530-D6CD85F75D45}" type="datetimeFigureOut">
+            <a:fld id="{1F8D42F4-7471-47FA-A915-491041C92066}" type="datetimeFigureOut">
               <a:rPr lang="en-US" smtClean="0"/>
-              <a:t>6/25/2026</a:t>
+              <a:t>6/26/2026</a:t>
             </a:fld>
             <a:endParaRPr lang="en-US"/>
           </a:p>
@@ -1962,7 +1962,7 @@
           <p:cNvPr id="4" name="Footer Placeholder 3">
             <a:extLst>
               <a:ext uri="{FF2B5EF4-FFF2-40B4-BE49-F238E27FC236}">
-                <a16:creationId xmlns:a16="http://schemas.microsoft.com/office/drawing/2014/main" id="{8074BD52-9A10-ED6E-5B9E-E685A5A3202D}"/>
+                <a16:creationId xmlns:a16="http://schemas.microsoft.com/office/drawing/2014/main" id="{EC9889F5-B5AA-9E66-4BD1-6640DBD11762}"/>
               </a:ext>
             </a:extLst>
           </p:cNvPr>
@@ -1987,7 +1987,7 @@
           <p:cNvPr id="5" name="Slide Number Placeholder 4">
             <a:extLst>
               <a:ext uri="{FF2B5EF4-FFF2-40B4-BE49-F238E27FC236}">
-                <a16:creationId xmlns:a16="http://schemas.microsoft.com/office/drawing/2014/main" id="{9EE0EA3B-05E3-DBC8-D474-2F7B9BD0A12C}"/>
+                <a16:creationId xmlns:a16="http://schemas.microsoft.com/office/drawing/2014/main" id="{0FD71945-518A-9553-9DC3-126A22EB4EBE}"/>
               </a:ext>
             </a:extLst>
           </p:cNvPr>
@@ -2003,7 +2003,7 @@
           <a:bodyPr/>
           <a:lstStyle/>
           <a:p>
-            <a:fld id="{69A9D669-6F5B-41F0-8144-61566721581D}" type="slidenum">
+            <a:fld id="{BCEB5019-9AEC-4FB4-9C3E-3AEB2984872B}" type="slidenum">
               <a:rPr lang="en-US" smtClean="0"/>
               <a:t>‹#›</a:t>
             </a:fld>
@@ -2014,7 +2014,7 @@
     </p:spTree>
     <p:extLst>
       <p:ext uri="{BB962C8B-B14F-4D97-AF65-F5344CB8AC3E}">
-        <p14:creationId xmlns:p14="http://schemas.microsoft.com/office/powerpoint/2010/main" val="2903749447"/>
+        <p14:creationId xmlns:p14="http://schemas.microsoft.com/office/powerpoint/2010/main" val="2454206841"/>
       </p:ext>
     </p:extLst>
   </p:cSld>
@@ -2046,7 +2046,7 @@
           <p:cNvPr id="2" name="Date Placeholder 1">
             <a:extLst>
               <a:ext uri="{FF2B5EF4-FFF2-40B4-BE49-F238E27FC236}">
-                <a16:creationId xmlns:a16="http://schemas.microsoft.com/office/drawing/2014/main" id="{9DF694DE-2D8D-D879-2FCE-A15C7FF7BDBA}"/>
+                <a16:creationId xmlns:a16="http://schemas.microsoft.com/office/drawing/2014/main" id="{39233C7F-535E-9169-64D5-40079E2EE59D}"/>
               </a:ext>
             </a:extLst>
           </p:cNvPr>
@@ -2062,9 +2062,9 @@
           <a:bodyPr/>
           <a:lstStyle/>
           <a:p>
-            <a:fld id="{DFA09FBC-30DC-48BE-8530-D6CD85F75D45}" type="datetimeFigureOut">
+            <a:fld id="{1F8D42F4-7471-47FA-A915-491041C92066}" type="datetimeFigureOut">
               <a:rPr lang="en-US" smtClean="0"/>
-              <a:t>6/25/2026</a:t>
+              <a:t>6/26/2026</a:t>
             </a:fld>
             <a:endParaRPr lang="en-US"/>
           </a:p>
@@ -2075,7 +2075,7 @@
           <p:cNvPr id="3" name="Footer Placeholder 2">
             <a:extLst>
               <a:ext uri="{FF2B5EF4-FFF2-40B4-BE49-F238E27FC236}">
-                <a16:creationId xmlns:a16="http://schemas.microsoft.com/office/drawing/2014/main" id="{BDF3E405-237F-00CC-B6A5-0D6E78826DE9}"/>
+                <a16:creationId xmlns:a16="http://schemas.microsoft.com/office/drawing/2014/main" id="{285EE309-0A59-D753-4527-1436A73E1DF6}"/>
               </a:ext>
             </a:extLst>
           </p:cNvPr>
@@ -2100,7 +2100,7 @@
           <p:cNvPr id="4" name="Slide Number Placeholder 3">
             <a:extLst>
               <a:ext uri="{FF2B5EF4-FFF2-40B4-BE49-F238E27FC236}">
-                <a16:creationId xmlns:a16="http://schemas.microsoft.com/office/drawing/2014/main" id="{617D8E23-7625-7261-20CA-2099A78FB76E}"/>
+                <a16:creationId xmlns:a16="http://schemas.microsoft.com/office/drawing/2014/main" id="{DFA6986F-5305-7673-8C40-A20222A83825}"/>
               </a:ext>
             </a:extLst>
           </p:cNvPr>
@@ -2116,7 +2116,7 @@
           <a:bodyPr/>
           <a:lstStyle/>
           <a:p>
-            <a:fld id="{69A9D669-6F5B-41F0-8144-61566721581D}" type="slidenum">
+            <a:fld id="{BCEB5019-9AEC-4FB4-9C3E-3AEB2984872B}" type="slidenum">
               <a:rPr lang="en-US" smtClean="0"/>
               <a:t>‹#›</a:t>
             </a:fld>
@@ -2127,7 +2127,7 @@
     </p:spTree>
     <p:extLst>
       <p:ext uri="{BB962C8B-B14F-4D97-AF65-F5344CB8AC3E}">
-        <p14:creationId xmlns:p14="http://schemas.microsoft.com/office/powerpoint/2010/main" val="3971640325"/>
+        <p14:creationId xmlns:p14="http://schemas.microsoft.com/office/powerpoint/2010/main" val="2792895128"/>
       </p:ext>
     </p:extLst>
   </p:cSld>
@@ -2159,7 +2159,7 @@
           <p:cNvPr id="2" name="Title 1">
             <a:extLst>
               <a:ext uri="{FF2B5EF4-FFF2-40B4-BE49-F238E27FC236}">
-                <a16:creationId xmlns:a16="http://schemas.microsoft.com/office/drawing/2014/main" id="{092BBAAB-C740-9C29-7CE3-EF06C42D0DCF}"/>
+                <a16:creationId xmlns:a16="http://schemas.microsoft.com/office/drawing/2014/main" id="{91F271E1-7B92-0660-040E-0093166B9693}"/>
               </a:ext>
             </a:extLst>
           </p:cNvPr>
@@ -2196,7 +2196,7 @@
           <p:cNvPr id="3" name="Content Placeholder 2">
             <a:extLst>
               <a:ext uri="{FF2B5EF4-FFF2-40B4-BE49-F238E27FC236}">
-                <a16:creationId xmlns:a16="http://schemas.microsoft.com/office/drawing/2014/main" id="{02F5C402-3A33-4293-7D6D-3749DB06363B}"/>
+                <a16:creationId xmlns:a16="http://schemas.microsoft.com/office/drawing/2014/main" id="{80DA935A-F7F3-8224-F7A7-1F07725D09D9}"/>
               </a:ext>
             </a:extLst>
           </p:cNvPr>
@@ -2286,7 +2286,7 @@
           <p:cNvPr id="4" name="Text Placeholder 3">
             <a:extLst>
               <a:ext uri="{FF2B5EF4-FFF2-40B4-BE49-F238E27FC236}">
-                <a16:creationId xmlns:a16="http://schemas.microsoft.com/office/drawing/2014/main" id="{B2290B98-DC24-67EE-35D0-76AE7D744972}"/>
+                <a16:creationId xmlns:a16="http://schemas.microsoft.com/office/drawing/2014/main" id="{D1D942FF-F3F6-AD6D-8F4C-D8717C23240D}"/>
               </a:ext>
             </a:extLst>
           </p:cNvPr>
@@ -2357,7 +2357,7 @@
           <p:cNvPr id="5" name="Date Placeholder 4">
             <a:extLst>
               <a:ext uri="{FF2B5EF4-FFF2-40B4-BE49-F238E27FC236}">
-                <a16:creationId xmlns:a16="http://schemas.microsoft.com/office/drawing/2014/main" id="{BB37EC92-6E1F-8708-8319-8CE3B0CDBFB2}"/>
+                <a16:creationId xmlns:a16="http://schemas.microsoft.com/office/drawing/2014/main" id="{04CD2637-A18D-D506-55D8-13EBB231C88F}"/>
               </a:ext>
             </a:extLst>
           </p:cNvPr>
@@ -2373,9 +2373,9 @@
           <a:bodyPr/>
           <a:lstStyle/>
           <a:p>
-            <a:fld id="{DFA09FBC-30DC-48BE-8530-D6CD85F75D45}" type="datetimeFigureOut">
+            <a:fld id="{1F8D42F4-7471-47FA-A915-491041C92066}" type="datetimeFigureOut">
               <a:rPr lang="en-US" smtClean="0"/>
-              <a:t>6/25/2026</a:t>
+              <a:t>6/26/2026</a:t>
             </a:fld>
             <a:endParaRPr lang="en-US"/>
           </a:p>
@@ -2386,7 +2386,7 @@
           <p:cNvPr id="6" name="Footer Placeholder 5">
             <a:extLst>
               <a:ext uri="{FF2B5EF4-FFF2-40B4-BE49-F238E27FC236}">
-                <a16:creationId xmlns:a16="http://schemas.microsoft.com/office/drawing/2014/main" id="{EBD40BEA-576B-BE80-80DC-23D162048088}"/>
+                <a16:creationId xmlns:a16="http://schemas.microsoft.com/office/drawing/2014/main" id="{EC1ABFDA-6D84-6C9D-5CB3-1C72D6281E60}"/>
               </a:ext>
             </a:extLst>
           </p:cNvPr>
@@ -2411,7 +2411,7 @@
           <p:cNvPr id="7" name="Slide Number Placeholder 6">
             <a:extLst>
               <a:ext uri="{FF2B5EF4-FFF2-40B4-BE49-F238E27FC236}">
-                <a16:creationId xmlns:a16="http://schemas.microsoft.com/office/drawing/2014/main" id="{0FB0216D-BDA6-AAD1-E0B0-7DF7D9AD655F}"/>
+                <a16:creationId xmlns:a16="http://schemas.microsoft.com/office/drawing/2014/main" id="{F812DED0-0EB4-F118-3368-CBFBB3BBE8F1}"/>
               </a:ext>
             </a:extLst>
           </p:cNvPr>
@@ -2427,7 +2427,7 @@
           <a:bodyPr/>
           <a:lstStyle/>
           <a:p>
-            <a:fld id="{69A9D669-6F5B-41F0-8144-61566721581D}" type="slidenum">
+            <a:fld id="{BCEB5019-9AEC-4FB4-9C3E-3AEB2984872B}" type="slidenum">
               <a:rPr lang="en-US" smtClean="0"/>
               <a:t>‹#›</a:t>
             </a:fld>
@@ -2438,7 +2438,7 @@
     </p:spTree>
     <p:extLst>
       <p:ext uri="{BB962C8B-B14F-4D97-AF65-F5344CB8AC3E}">
-        <p14:creationId xmlns:p14="http://schemas.microsoft.com/office/powerpoint/2010/main" val="21006010"/>
+        <p14:creationId xmlns:p14="http://schemas.microsoft.com/office/powerpoint/2010/main" val="3621262438"/>
       </p:ext>
     </p:extLst>
   </p:cSld>
@@ -2470,7 +2470,7 @@
           <p:cNvPr id="2" name="Title 1">
             <a:extLst>
               <a:ext uri="{FF2B5EF4-FFF2-40B4-BE49-F238E27FC236}">
-                <a16:creationId xmlns:a16="http://schemas.microsoft.com/office/drawing/2014/main" id="{A4A77FD9-558D-0100-3CA7-37AC5C8A80F2}"/>
+                <a16:creationId xmlns:a16="http://schemas.microsoft.com/office/drawing/2014/main" id="{77DA267A-80EE-AC99-C537-3058C46E73FE}"/>
               </a:ext>
             </a:extLst>
           </p:cNvPr>
@@ -2507,7 +2507,7 @@
           <p:cNvPr id="3" name="Picture Placeholder 2">
             <a:extLst>
               <a:ext uri="{FF2B5EF4-FFF2-40B4-BE49-F238E27FC236}">
-                <a16:creationId xmlns:a16="http://schemas.microsoft.com/office/drawing/2014/main" id="{A0CFB07D-4FD4-E333-077E-9D37D0383B73}"/>
+                <a16:creationId xmlns:a16="http://schemas.microsoft.com/office/drawing/2014/main" id="{85F042E9-050E-BF55-7481-09B48542ED6B}"/>
               </a:ext>
             </a:extLst>
           </p:cNvPr>
@@ -2574,7 +2574,7 @@
           <p:cNvPr id="4" name="Text Placeholder 3">
             <a:extLst>
               <a:ext uri="{FF2B5EF4-FFF2-40B4-BE49-F238E27FC236}">
-                <a16:creationId xmlns:a16="http://schemas.microsoft.com/office/drawing/2014/main" id="{5F6FB45B-52B2-A024-9B25-000683959216}"/>
+                <a16:creationId xmlns:a16="http://schemas.microsoft.com/office/drawing/2014/main" id="{127C5AAC-C7B8-CFC8-2F11-470A1413A07D}"/>
               </a:ext>
             </a:extLst>
           </p:cNvPr>
@@ -2645,7 +2645,7 @@
           <p:cNvPr id="5" name="Date Placeholder 4">
             <a:extLst>
               <a:ext uri="{FF2B5EF4-FFF2-40B4-BE49-F238E27FC236}">
-                <a16:creationId xmlns:a16="http://schemas.microsoft.com/office/drawing/2014/main" id="{ED0479AE-0597-FE7B-3923-794E25ADE7C1}"/>
+                <a16:creationId xmlns:a16="http://schemas.microsoft.com/office/drawing/2014/main" id="{A2F78DBB-8A7F-1223-41EB-F0C66149E703}"/>
               </a:ext>
             </a:extLst>
           </p:cNvPr>
@@ -2661,9 +2661,9 @@
           <a:bodyPr/>
           <a:lstStyle/>
           <a:p>
-            <a:fld id="{DFA09FBC-30DC-48BE-8530-D6CD85F75D45}" type="datetimeFigureOut">
+            <a:fld id="{1F8D42F4-7471-47FA-A915-491041C92066}" type="datetimeFigureOut">
               <a:rPr lang="en-US" smtClean="0"/>
-              <a:t>6/25/2026</a:t>
+              <a:t>6/26/2026</a:t>
             </a:fld>
             <a:endParaRPr lang="en-US"/>
           </a:p>
@@ -2674,7 +2674,7 @@
           <p:cNvPr id="6" name="Footer Placeholder 5">
             <a:extLst>
               <a:ext uri="{FF2B5EF4-FFF2-40B4-BE49-F238E27FC236}">
-                <a16:creationId xmlns:a16="http://schemas.microsoft.com/office/drawing/2014/main" id="{EFB29B26-BB99-811A-1A93-BBEF8556DD2D}"/>
+                <a16:creationId xmlns:a16="http://schemas.microsoft.com/office/drawing/2014/main" id="{BD6F1A53-A642-4C2E-1196-65A3BA6F95DC}"/>
               </a:ext>
             </a:extLst>
           </p:cNvPr>
@@ -2699,7 +2699,7 @@
           <p:cNvPr id="7" name="Slide Number Placeholder 6">
             <a:extLst>
               <a:ext uri="{FF2B5EF4-FFF2-40B4-BE49-F238E27FC236}">
-                <a16:creationId xmlns:a16="http://schemas.microsoft.com/office/drawing/2014/main" id="{ED8E0F56-4C4D-3035-66D5-3F9BD24FC401}"/>
+                <a16:creationId xmlns:a16="http://schemas.microsoft.com/office/drawing/2014/main" id="{2A55F1B0-53CB-DCD2-F302-2D96F1F452E1}"/>
               </a:ext>
             </a:extLst>
           </p:cNvPr>
@@ -2715,7 +2715,7 @@
           <a:bodyPr/>
           <a:lstStyle/>
           <a:p>
-            <a:fld id="{69A9D669-6F5B-41F0-8144-61566721581D}" type="slidenum">
+            <a:fld id="{BCEB5019-9AEC-4FB4-9C3E-3AEB2984872B}" type="slidenum">
               <a:rPr lang="en-US" smtClean="0"/>
               <a:t>‹#›</a:t>
             </a:fld>
@@ -2726,7 +2726,7 @@
     </p:spTree>
     <p:extLst>
       <p:ext uri="{BB962C8B-B14F-4D97-AF65-F5344CB8AC3E}">
-        <p14:creationId xmlns:p14="http://schemas.microsoft.com/office/powerpoint/2010/main" val="784279951"/>
+        <p14:creationId xmlns:p14="http://schemas.microsoft.com/office/powerpoint/2010/main" val="1037915573"/>
       </p:ext>
     </p:extLst>
   </p:cSld>
@@ -2763,7 +2763,7 @@
           <p:cNvPr id="2" name="Title Placeholder 1">
             <a:extLst>
               <a:ext uri="{FF2B5EF4-FFF2-40B4-BE49-F238E27FC236}">
-                <a16:creationId xmlns:a16="http://schemas.microsoft.com/office/drawing/2014/main" id="{DC2A4D20-F8E9-563C-DB08-82C1046C5BFA}"/>
+                <a16:creationId xmlns:a16="http://schemas.microsoft.com/office/drawing/2014/main" id="{265A2EF4-71D0-A134-8C55-CB6CC6EB1BA4}"/>
               </a:ext>
             </a:extLst>
           </p:cNvPr>
@@ -2801,7 +2801,7 @@
           <p:cNvPr id="3" name="Text Placeholder 2">
             <a:extLst>
               <a:ext uri="{FF2B5EF4-FFF2-40B4-BE49-F238E27FC236}">
-                <a16:creationId xmlns:a16="http://schemas.microsoft.com/office/drawing/2014/main" id="{4480BF9F-7B44-583D-DB0B-32DBE704ED2B}"/>
+                <a16:creationId xmlns:a16="http://schemas.microsoft.com/office/drawing/2014/main" id="{BF0B431D-ED39-35A4-6EB2-2D9ADE69604D}"/>
               </a:ext>
             </a:extLst>
           </p:cNvPr>
@@ -2868,7 +2868,7 @@
           <p:cNvPr id="4" name="Date Placeholder 3">
             <a:extLst>
               <a:ext uri="{FF2B5EF4-FFF2-40B4-BE49-F238E27FC236}">
-                <a16:creationId xmlns:a16="http://schemas.microsoft.com/office/drawing/2014/main" id="{4F4DE2CA-3044-B62E-F9F2-86957E200B14}"/>
+                <a16:creationId xmlns:a16="http://schemas.microsoft.com/office/drawing/2014/main" id="{13178FCE-B6F3-9EB4-EDE1-2D7663454736}"/>
               </a:ext>
             </a:extLst>
           </p:cNvPr>
@@ -2902,9 +2902,9 @@
             </a:lvl1pPr>
           </a:lstStyle>
           <a:p>
-            <a:fld id="{DFA09FBC-30DC-48BE-8530-D6CD85F75D45}" type="datetimeFigureOut">
+            <a:fld id="{1F8D42F4-7471-47FA-A915-491041C92066}" type="datetimeFigureOut">
               <a:rPr lang="en-US" smtClean="0"/>
-              <a:t>6/25/2026</a:t>
+              <a:t>6/26/2026</a:t>
             </a:fld>
             <a:endParaRPr lang="en-US"/>
           </a:p>
@@ -2915,7 +2915,7 @@
           <p:cNvPr id="5" name="Footer Placeholder 4">
             <a:extLst>
               <a:ext uri="{FF2B5EF4-FFF2-40B4-BE49-F238E27FC236}">
-                <a16:creationId xmlns:a16="http://schemas.microsoft.com/office/drawing/2014/main" id="{2F8CD0F0-F9E0-C275-82CB-8A929460C2BD}"/>
+                <a16:creationId xmlns:a16="http://schemas.microsoft.com/office/drawing/2014/main" id="{4AEFB256-E1B9-BC5E-391A-2EB21418C79A}"/>
               </a:ext>
             </a:extLst>
           </p:cNvPr>
@@ -2958,7 +2958,7 @@
           <p:cNvPr id="6" name="Slide Number Placeholder 5">
             <a:extLst>
               <a:ext uri="{FF2B5EF4-FFF2-40B4-BE49-F238E27FC236}">
-                <a16:creationId xmlns:a16="http://schemas.microsoft.com/office/drawing/2014/main" id="{0DDB6D36-88D8-58B4-D373-5A788855D8AB}"/>
+                <a16:creationId xmlns:a16="http://schemas.microsoft.com/office/drawing/2014/main" id="{6A8C1F6D-485B-8942-0717-880C2D22AD3F}"/>
               </a:ext>
             </a:extLst>
           </p:cNvPr>
@@ -2992,7 +2992,7 @@
             </a:lvl1pPr>
           </a:lstStyle>
           <a:p>
-            <a:fld id="{69A9D669-6F5B-41F0-8144-61566721581D}" type="slidenum">
+            <a:fld id="{BCEB5019-9AEC-4FB4-9C3E-3AEB2984872B}" type="slidenum">
               <a:rPr lang="en-US" smtClean="0"/>
               <a:t>‹#›</a:t>
             </a:fld>
@@ -3003,7 +3003,7 @@
     </p:spTree>
     <p:extLst>
       <p:ext uri="{BB962C8B-B14F-4D97-AF65-F5344CB8AC3E}">
-        <p14:creationId xmlns:p14="http://schemas.microsoft.com/office/powerpoint/2010/main" val="3934274030"/>
+        <p14:creationId xmlns:p14="http://schemas.microsoft.com/office/powerpoint/2010/main" val="1743411745"/>
       </p:ext>
     </p:extLst>
   </p:cSld>
@@ -3326,7 +3326,7 @@
           <p:cNvPr id="2" name="Title 1">
             <a:extLst>
               <a:ext uri="{FF2B5EF4-FFF2-40B4-BE49-F238E27FC236}">
-                <a16:creationId xmlns:a16="http://schemas.microsoft.com/office/drawing/2014/main" id="{3330DEC1-1998-57B6-4C9F-838CFC8DE160}"/>
+                <a16:creationId xmlns:a16="http://schemas.microsoft.com/office/drawing/2014/main" id="{A49F0E3C-3584-0E81-7AB7-7D1B3E477269}"/>
               </a:ext>
             </a:extLst>
           </p:cNvPr>
@@ -3356,7 +3356,7 @@
           <p:cNvPr id="3" name="Subtitle 2">
             <a:extLst>
               <a:ext uri="{FF2B5EF4-FFF2-40B4-BE49-F238E27FC236}">
-                <a16:creationId xmlns:a16="http://schemas.microsoft.com/office/drawing/2014/main" id="{51C0F20D-F6F2-5998-5BEC-22D6C1D21480}"/>
+                <a16:creationId xmlns:a16="http://schemas.microsoft.com/office/drawing/2014/main" id="{57293398-C131-40F6-12D3-973E3BB38D62}"/>
               </a:ext>
             </a:extLst>
           </p:cNvPr>
@@ -3384,7 +3384,7 @@
     </p:spTree>
     <p:extLst>
       <p:ext uri="{BB962C8B-B14F-4D97-AF65-F5344CB8AC3E}">
-        <p14:creationId xmlns:p14="http://schemas.microsoft.com/office/powerpoint/2010/main" val="1484415328"/>
+        <p14:creationId xmlns:p14="http://schemas.microsoft.com/office/powerpoint/2010/main" val="2690538213"/>
       </p:ext>
     </p:extLst>
   </p:cSld>

</xml_diff>